<commit_message>
Clarify poster contributions, use cases and evidence boundaries
</commit_message>
<xml_diff>
--- a/docs/dcs-poster-v10-3/DCS_2026_학술대회포스터_v10_3_A0.pptx
+++ b/docs/dcs-poster-v10-3/DCS_2026_학술대회포스터_v10_3_A0.pptx
@@ -2,13 +2,13 @@
 <file path=ppt/presentation.xml><?xml version="1.0" encoding="utf-8"?>
 <p:presentation xmlns:p="http://schemas.openxmlformats.org/presentationml/2006/main">
   <p:sldMasterIdLst>
-    <p:sldMasterId xmlns:r="http://schemas.openxmlformats.org/officeDocument/2006/relationships" id="2147483648" r:id="Rd9365062aaa04f3e"/>
+    <p:sldMasterId xmlns:r="http://schemas.openxmlformats.org/officeDocument/2006/relationships" id="2147483648" r:id="Rb2001f501a914fa4"/>
   </p:sldMasterIdLst>
   <p:notesMasterIdLst>
-    <p:notesMasterId xmlns:r="http://schemas.openxmlformats.org/officeDocument/2006/relationships" r:id="Rcfe6771c627d4d39"/>
+    <p:notesMasterId xmlns:r="http://schemas.openxmlformats.org/officeDocument/2006/relationships" r:id="R85b4185acf144e35"/>
   </p:notesMasterIdLst>
   <p:sldIdLst>
-    <p:sldId xmlns:r="http://schemas.openxmlformats.org/officeDocument/2006/relationships" id="256" r:id="Rfa96318d55ac4af4"/>
+    <p:sldId xmlns:r="http://schemas.openxmlformats.org/officeDocument/2006/relationships" id="256" r:id="R69054005af64476e"/>
   </p:sldIdLst>
   <p:sldSz cx="30276000" cy="42804000"/>
   <p:notesSz cx="6858000" cy="9144000"/>
@@ -475,6 +475,11 @@
               <a:t>https://archive.ics.uci.edu/dataset/240/human+activity+recognition+using+smartphones</a:t>
             </a:r>
           </a:p>
+          <a:p xmlns:a="http://schemas.openxmlformats.org/drawingml/2006/main">
+            <a:r>
+              <a:t>포스터 r1: 입력 대조와 시계열 입력 구분, 대표 F1 집계 단위, 검증 첫 구간의 PC 비용, 오류 2개 중첩 구간과 활용 출력 범위를 본문에 명시. 새 학습·시험 수치는 없다.</a:t>
+            </a:r>
+          </a:p>
         </p:txBody>
       </p:sp>
       <p:sp>
@@ -2915,12 +2920,12 @@
   </p:cSld>
   <p:clrMap bg1="lt1" tx1="dk1" bg2="lt2" tx2="dk2" accent1="accent1" accent2="accent2" accent3="accent3" accent4="accent4" accent5="accent5" accent6="accent6" hlink="hlink" folHlink="folHlink"/>
   <p:sldLayoutIdLst>
-    <p:sldLayoutId xmlns:r="http://schemas.openxmlformats.org/officeDocument/2006/relationships" id="2147483649" r:id="R9ee67a9633d64f91"/>
-    <p:sldLayoutId xmlns:r="http://schemas.openxmlformats.org/officeDocument/2006/relationships" id="2147483650" r:id="R76f75b3fb8aa4d97"/>
-    <p:sldLayoutId xmlns:r="http://schemas.openxmlformats.org/officeDocument/2006/relationships" id="2147483651" r:id="Rd89c09638ef247c5"/>
-    <p:sldLayoutId xmlns:r="http://schemas.openxmlformats.org/officeDocument/2006/relationships" id="2147483652" r:id="Rf020db4c580e47f2"/>
-    <p:sldLayoutId xmlns:r="http://schemas.openxmlformats.org/officeDocument/2006/relationships" id="2147483653" r:id="R0ab600d8f5104bb1"/>
-    <p:sldLayoutId xmlns:r="http://schemas.openxmlformats.org/officeDocument/2006/relationships" id="2147483654" r:id="Rfbf99c99ae6f424d"/>
+    <p:sldLayoutId xmlns:r="http://schemas.openxmlformats.org/officeDocument/2006/relationships" id="2147483649" r:id="R32d5d8cd4ce54cc0"/>
+    <p:sldLayoutId xmlns:r="http://schemas.openxmlformats.org/officeDocument/2006/relationships" id="2147483650" r:id="R380ab9d29bd74edd"/>
+    <p:sldLayoutId xmlns:r="http://schemas.openxmlformats.org/officeDocument/2006/relationships" id="2147483651" r:id="R58b3cf6f66174ec3"/>
+    <p:sldLayoutId xmlns:r="http://schemas.openxmlformats.org/officeDocument/2006/relationships" id="2147483652" r:id="R8b1784330fa941c0"/>
+    <p:sldLayoutId xmlns:r="http://schemas.openxmlformats.org/officeDocument/2006/relationships" id="2147483653" r:id="R161a42f54e614b98"/>
+    <p:sldLayoutId xmlns:r="http://schemas.openxmlformats.org/officeDocument/2006/relationships" id="2147483654" r:id="Re599e0ff9c0144a5"/>
   </p:sldLayoutIdLst>
   <p:txStyles>
     <p:titleStyle>
@@ -6384,6 +6389,7 @@
               </a:defRPr>
             </a:defPPr>
             <a:lvl1pPr>
+              <a:buNone/>
               <a:defRPr sz="3300" b="0">
                 <a:solidFill>
                   <a:srgbClr val="4C606E"/>
@@ -6394,6 +6400,7 @@
               </a:defRPr>
             </a:lvl1pPr>
             <a:lvl2pPr>
+              <a:buNone/>
               <a:defRPr sz="3300" b="0">
                 <a:solidFill>
                   <a:srgbClr val="4C606E"/>
@@ -6404,6 +6411,7 @@
               </a:defRPr>
             </a:lvl2pPr>
             <a:lvl3pPr>
+              <a:buNone/>
               <a:defRPr sz="3300" b="0">
                 <a:solidFill>
                   <a:srgbClr val="4C606E"/>
@@ -6414,6 +6422,7 @@
               </a:defRPr>
             </a:lvl3pPr>
             <a:lvl4pPr>
+              <a:buNone/>
               <a:defRPr sz="3300" b="0">
                 <a:solidFill>
                   <a:srgbClr val="4C606E"/>
@@ -6424,6 +6433,7 @@
               </a:defRPr>
             </a:lvl4pPr>
             <a:lvl5pPr>
+              <a:buNone/>
               <a:defRPr sz="3300" b="0">
                 <a:solidFill>
                   <a:srgbClr val="4C606E"/>
@@ -6434,6 +6444,7 @@
               </a:defRPr>
             </a:lvl5pPr>
             <a:lvl6pPr>
+              <a:buNone/>
               <a:defRPr sz="3300" b="0">
                 <a:solidFill>
                   <a:srgbClr val="4C606E"/>
@@ -6444,6 +6455,7 @@
               </a:defRPr>
             </a:lvl6pPr>
             <a:lvl7pPr>
+              <a:buNone/>
               <a:defRPr sz="3300" b="0">
                 <a:solidFill>
                   <a:srgbClr val="4C606E"/>
@@ -6454,6 +6466,7 @@
               </a:defRPr>
             </a:lvl7pPr>
             <a:lvl8pPr>
+              <a:buNone/>
               <a:defRPr sz="3300" b="0">
                 <a:solidFill>
                   <a:srgbClr val="4C606E"/>
@@ -6464,6 +6477,7 @@
               </a:defRPr>
             </a:lvl8pPr>
             <a:lvl9pPr>
+              <a:buNone/>
               <a:defRPr sz="3300" b="0">
                 <a:solidFill>
                   <a:srgbClr val="4C606E"/>
@@ -6476,6 +6490,7 @@
           </a:lstStyle>
           <a:p xmlns:a="http://schemas.openxmlformats.org/drawingml/2006/main">
             <a:pPr>
+              <a:buNone/>
               <a:defRPr sz="3300" b="0">
                 <a:solidFill>
                   <a:srgbClr val="4C606E"/>
@@ -6542,6 +6557,7 @@
               </a:defRPr>
             </a:defPPr>
             <a:lvl1pPr>
+              <a:buNone/>
               <a:defRPr sz="8550" b="1">
                 <a:solidFill>
                   <a:srgbClr val="132F43"/>
@@ -6552,6 +6568,7 @@
               </a:defRPr>
             </a:lvl1pPr>
             <a:lvl2pPr>
+              <a:buNone/>
               <a:defRPr sz="8550" b="1">
                 <a:solidFill>
                   <a:srgbClr val="132F43"/>
@@ -6562,6 +6579,7 @@
               </a:defRPr>
             </a:lvl2pPr>
             <a:lvl3pPr>
+              <a:buNone/>
               <a:defRPr sz="8550" b="1">
                 <a:solidFill>
                   <a:srgbClr val="132F43"/>
@@ -6572,6 +6590,7 @@
               </a:defRPr>
             </a:lvl3pPr>
             <a:lvl4pPr>
+              <a:buNone/>
               <a:defRPr sz="8550" b="1">
                 <a:solidFill>
                   <a:srgbClr val="132F43"/>
@@ -6582,6 +6601,7 @@
               </a:defRPr>
             </a:lvl4pPr>
             <a:lvl5pPr>
+              <a:buNone/>
               <a:defRPr sz="8550" b="1">
                 <a:solidFill>
                   <a:srgbClr val="132F43"/>
@@ -6592,6 +6612,7 @@
               </a:defRPr>
             </a:lvl5pPr>
             <a:lvl6pPr>
+              <a:buNone/>
               <a:defRPr sz="8550" b="1">
                 <a:solidFill>
                   <a:srgbClr val="132F43"/>
@@ -6602,6 +6623,7 @@
               </a:defRPr>
             </a:lvl6pPr>
             <a:lvl7pPr>
+              <a:buNone/>
               <a:defRPr sz="8550" b="1">
                 <a:solidFill>
                   <a:srgbClr val="132F43"/>
@@ -6612,6 +6634,7 @@
               </a:defRPr>
             </a:lvl7pPr>
             <a:lvl8pPr>
+              <a:buNone/>
               <a:defRPr sz="8550" b="1">
                 <a:solidFill>
                   <a:srgbClr val="132F43"/>
@@ -6622,6 +6645,7 @@
               </a:defRPr>
             </a:lvl8pPr>
             <a:lvl9pPr>
+              <a:buNone/>
               <a:defRPr sz="8550" b="1">
                 <a:solidFill>
                   <a:srgbClr val="132F43"/>
@@ -6634,6 +6658,7 @@
           </a:lstStyle>
           <a:p xmlns:a="http://schemas.openxmlformats.org/drawingml/2006/main">
             <a:pPr>
+              <a:buNone/>
               <a:defRPr sz="8550" b="1">
                 <a:solidFill>
                   <a:srgbClr val="132F43"/>
@@ -6657,6 +6682,7 @@
           </a:p>
           <a:p xmlns:a="http://schemas.openxmlformats.org/drawingml/2006/main">
             <a:pPr>
+              <a:buNone/>
               <a:defRPr sz="8550" b="1">
                 <a:solidFill>
                   <a:srgbClr val="132F43"/>
@@ -6723,6 +6749,7 @@
               </a:defRPr>
             </a:defPPr>
             <a:lvl1pPr>
+              <a:buNone/>
               <a:defRPr sz="4650" b="1">
                 <a:solidFill>
                   <a:srgbClr val="132F43"/>
@@ -6733,6 +6760,7 @@
               </a:defRPr>
             </a:lvl1pPr>
             <a:lvl2pPr>
+              <a:buNone/>
               <a:defRPr sz="4650" b="1">
                 <a:solidFill>
                   <a:srgbClr val="132F43"/>
@@ -6743,6 +6771,7 @@
               </a:defRPr>
             </a:lvl2pPr>
             <a:lvl3pPr>
+              <a:buNone/>
               <a:defRPr sz="4650" b="1">
                 <a:solidFill>
                   <a:srgbClr val="132F43"/>
@@ -6753,6 +6782,7 @@
               </a:defRPr>
             </a:lvl3pPr>
             <a:lvl4pPr>
+              <a:buNone/>
               <a:defRPr sz="4650" b="1">
                 <a:solidFill>
                   <a:srgbClr val="132F43"/>
@@ -6763,6 +6793,7 @@
               </a:defRPr>
             </a:lvl4pPr>
             <a:lvl5pPr>
+              <a:buNone/>
               <a:defRPr sz="4650" b="1">
                 <a:solidFill>
                   <a:srgbClr val="132F43"/>
@@ -6773,6 +6804,7 @@
               </a:defRPr>
             </a:lvl5pPr>
             <a:lvl6pPr>
+              <a:buNone/>
               <a:defRPr sz="4650" b="1">
                 <a:solidFill>
                   <a:srgbClr val="132F43"/>
@@ -6783,6 +6815,7 @@
               </a:defRPr>
             </a:lvl6pPr>
             <a:lvl7pPr>
+              <a:buNone/>
               <a:defRPr sz="4650" b="1">
                 <a:solidFill>
                   <a:srgbClr val="132F43"/>
@@ -6793,6 +6826,7 @@
               </a:defRPr>
             </a:lvl7pPr>
             <a:lvl8pPr>
+              <a:buNone/>
               <a:defRPr sz="4650" b="1">
                 <a:solidFill>
                   <a:srgbClr val="132F43"/>
@@ -6803,6 +6837,7 @@
               </a:defRPr>
             </a:lvl8pPr>
             <a:lvl9pPr>
+              <a:buNone/>
               <a:defRPr sz="4650" b="1">
                 <a:solidFill>
                   <a:srgbClr val="132F43"/>
@@ -6815,6 +6850,7 @@
           </a:lstStyle>
           <a:p xmlns:a="http://schemas.openxmlformats.org/drawingml/2006/main">
             <a:pPr>
+              <a:buNone/>
               <a:defRPr sz="4650" b="1">
                 <a:solidFill>
                   <a:srgbClr val="132F43"/>
@@ -6881,6 +6917,7 @@
               </a:defRPr>
             </a:defPPr>
             <a:lvl1pPr>
+              <a:buNone/>
               <a:defRPr sz="3525" b="0">
                 <a:solidFill>
                   <a:srgbClr val="132F43"/>
@@ -6891,6 +6928,7 @@
               </a:defRPr>
             </a:lvl1pPr>
             <a:lvl2pPr>
+              <a:buNone/>
               <a:defRPr sz="3525" b="0">
                 <a:solidFill>
                   <a:srgbClr val="132F43"/>
@@ -6901,6 +6939,7 @@
               </a:defRPr>
             </a:lvl2pPr>
             <a:lvl3pPr>
+              <a:buNone/>
               <a:defRPr sz="3525" b="0">
                 <a:solidFill>
                   <a:srgbClr val="132F43"/>
@@ -6911,6 +6950,7 @@
               </a:defRPr>
             </a:lvl3pPr>
             <a:lvl4pPr>
+              <a:buNone/>
               <a:defRPr sz="3525" b="0">
                 <a:solidFill>
                   <a:srgbClr val="132F43"/>
@@ -6921,6 +6961,7 @@
               </a:defRPr>
             </a:lvl4pPr>
             <a:lvl5pPr>
+              <a:buNone/>
               <a:defRPr sz="3525" b="0">
                 <a:solidFill>
                   <a:srgbClr val="132F43"/>
@@ -6931,6 +6972,7 @@
               </a:defRPr>
             </a:lvl5pPr>
             <a:lvl6pPr>
+              <a:buNone/>
               <a:defRPr sz="3525" b="0">
                 <a:solidFill>
                   <a:srgbClr val="132F43"/>
@@ -6941,6 +6983,7 @@
               </a:defRPr>
             </a:lvl6pPr>
             <a:lvl7pPr>
+              <a:buNone/>
               <a:defRPr sz="3525" b="0">
                 <a:solidFill>
                   <a:srgbClr val="132F43"/>
@@ -6951,6 +6994,7 @@
               </a:defRPr>
             </a:lvl7pPr>
             <a:lvl8pPr>
+              <a:buNone/>
               <a:defRPr sz="3525" b="0">
                 <a:solidFill>
                   <a:srgbClr val="132F43"/>
@@ -6961,6 +7005,7 @@
               </a:defRPr>
             </a:lvl8pPr>
             <a:lvl9pPr>
+              <a:buNone/>
               <a:defRPr sz="3525" b="0">
                 <a:solidFill>
                   <a:srgbClr val="132F43"/>
@@ -6973,6 +7018,7 @@
           </a:lstStyle>
           <a:p xmlns:a="http://schemas.openxmlformats.org/drawingml/2006/main">
             <a:pPr>
+              <a:buNone/>
               <a:defRPr sz="3525" b="0">
                 <a:solidFill>
                   <a:srgbClr val="132F43"/>
@@ -7029,7 +7075,7 @@
           </a:bodyPr>
           <a:lstStyle xmlns:a="http://schemas.openxmlformats.org/drawingml/2006/main">
             <a:defPPr>
-              <a:defRPr sz="4500" b="1">
+              <a:defRPr sz="4350" b="1">
                 <a:solidFill>
                   <a:srgbClr val="087F8C"/>
                 </a:solidFill>
@@ -7039,6 +7085,7 @@
               </a:defRPr>
             </a:defPPr>
             <a:lvl1pPr>
+              <a:buNone/>
               <a:defRPr sz="4500" b="1">
                 <a:solidFill>
                   <a:srgbClr val="087F8C"/>
@@ -7049,6 +7096,7 @@
               </a:defRPr>
             </a:lvl1pPr>
             <a:lvl2pPr>
+              <a:buNone/>
               <a:defRPr sz="4500" b="1">
                 <a:solidFill>
                   <a:srgbClr val="087F8C"/>
@@ -7059,6 +7107,7 @@
               </a:defRPr>
             </a:lvl2pPr>
             <a:lvl3pPr>
+              <a:buNone/>
               <a:defRPr sz="4500" b="1">
                 <a:solidFill>
                   <a:srgbClr val="087F8C"/>
@@ -7069,6 +7118,7 @@
               </a:defRPr>
             </a:lvl3pPr>
             <a:lvl4pPr>
+              <a:buNone/>
               <a:defRPr sz="4500" b="1">
                 <a:solidFill>
                   <a:srgbClr val="087F8C"/>
@@ -7079,6 +7129,7 @@
               </a:defRPr>
             </a:lvl4pPr>
             <a:lvl5pPr>
+              <a:buNone/>
               <a:defRPr sz="4500" b="1">
                 <a:solidFill>
                   <a:srgbClr val="087F8C"/>
@@ -7089,6 +7140,7 @@
               </a:defRPr>
             </a:lvl5pPr>
             <a:lvl6pPr>
+              <a:buNone/>
               <a:defRPr sz="4500" b="1">
                 <a:solidFill>
                   <a:srgbClr val="087F8C"/>
@@ -7099,6 +7151,7 @@
               </a:defRPr>
             </a:lvl6pPr>
             <a:lvl7pPr>
+              <a:buNone/>
               <a:defRPr sz="4500" b="1">
                 <a:solidFill>
                   <a:srgbClr val="087F8C"/>
@@ -7109,6 +7162,7 @@
               </a:defRPr>
             </a:lvl7pPr>
             <a:lvl8pPr>
+              <a:buNone/>
               <a:defRPr sz="4500" b="1">
                 <a:solidFill>
                   <a:srgbClr val="087F8C"/>
@@ -7119,6 +7173,7 @@
               </a:defRPr>
             </a:lvl8pPr>
             <a:lvl9pPr>
+              <a:buNone/>
               <a:defRPr sz="4500" b="1">
                 <a:solidFill>
                   <a:srgbClr val="087F8C"/>
@@ -7131,7 +7186,8 @@
           </a:lstStyle>
           <a:p xmlns:a="http://schemas.openxmlformats.org/drawingml/2006/main">
             <a:pPr>
-              <a:defRPr sz="4500" b="1">
+              <a:buNone/>
+              <a:defRPr sz="4350" b="1">
                 <a:solidFill>
                   <a:srgbClr val="087F8C"/>
                 </a:solidFill>
@@ -7141,7 +7197,7 @@
               </a:defRPr>
             </a:pPr>
             <a:r>
-              <a:rPr sz="4500" b="1">
+              <a:rPr sz="4350" b="1">
                 <a:solidFill>
                   <a:srgbClr val="087F8C"/>
                 </a:solidFill>
@@ -7149,7 +7205,31 @@
                 <a:ea typeface="Malgun Gothic"/>
                 <a:cs typeface="Malgun Gothic"/>
               </a:rPr>
-              <a:t>필요한 행동 정보를 먼저 정하고, 높은 성능을 보인 구성의 처리 비용을 비교한다</a:t>
+              <a:t>활동 요약은 3상태 성능·비용으로,</a:t>
+            </a:r>
+          </a:p>
+          <a:p xmlns:a="http://schemas.openxmlformats.org/drawingml/2006/main">
+            <a:pPr>
+              <a:buNone/>
+              <a:defRPr sz="4350" b="1">
+                <a:solidFill>
+                  <a:srgbClr val="087F8C"/>
+                </a:solidFill>
+                <a:latin typeface="Malgun Gothic"/>
+                <a:ea typeface="Malgun Gothic"/>
+                <a:cs typeface="Malgun Gothic"/>
+              </a:defRPr>
+            </a:pPr>
+            <a:r>
+              <a:rPr sz="4350" b="1">
+                <a:solidFill>
+                  <a:srgbClr val="087F8C"/>
+                </a:solidFill>
+                <a:latin typeface="Malgun Gothic"/>
+                <a:ea typeface="Malgun Gothic"/>
+                <a:cs typeface="Malgun Gothic"/>
+              </a:rPr>
+              <a:t>세부 행동 기록은 필요한 라벨을 보존해 선택한다</a:t>
             </a:r>
           </a:p>
         </p:txBody>
@@ -7197,6 +7277,7 @@
               </a:defRPr>
             </a:defPPr>
             <a:lvl1pPr>
+              <a:buNone/>
               <a:defRPr sz="4650" b="1">
                 <a:solidFill>
                   <a:srgbClr val="087F8C"/>
@@ -7207,6 +7288,7 @@
               </a:defRPr>
             </a:lvl1pPr>
             <a:lvl2pPr>
+              <a:buNone/>
               <a:defRPr sz="4650" b="1">
                 <a:solidFill>
                   <a:srgbClr val="087F8C"/>
@@ -7217,6 +7299,7 @@
               </a:defRPr>
             </a:lvl2pPr>
             <a:lvl3pPr>
+              <a:buNone/>
               <a:defRPr sz="4650" b="1">
                 <a:solidFill>
                   <a:srgbClr val="087F8C"/>
@@ -7227,6 +7310,7 @@
               </a:defRPr>
             </a:lvl3pPr>
             <a:lvl4pPr>
+              <a:buNone/>
               <a:defRPr sz="4650" b="1">
                 <a:solidFill>
                   <a:srgbClr val="087F8C"/>
@@ -7237,6 +7321,7 @@
               </a:defRPr>
             </a:lvl4pPr>
             <a:lvl5pPr>
+              <a:buNone/>
               <a:defRPr sz="4650" b="1">
                 <a:solidFill>
                   <a:srgbClr val="087F8C"/>
@@ -7247,6 +7332,7 @@
               </a:defRPr>
             </a:lvl5pPr>
             <a:lvl6pPr>
+              <a:buNone/>
               <a:defRPr sz="4650" b="1">
                 <a:solidFill>
                   <a:srgbClr val="087F8C"/>
@@ -7257,6 +7343,7 @@
               </a:defRPr>
             </a:lvl6pPr>
             <a:lvl7pPr>
+              <a:buNone/>
               <a:defRPr sz="4650" b="1">
                 <a:solidFill>
                   <a:srgbClr val="087F8C"/>
@@ -7267,6 +7354,7 @@
               </a:defRPr>
             </a:lvl7pPr>
             <a:lvl8pPr>
+              <a:buNone/>
               <a:defRPr sz="4650" b="1">
                 <a:solidFill>
                   <a:srgbClr val="087F8C"/>
@@ -7277,6 +7365,7 @@
               </a:defRPr>
             </a:lvl8pPr>
             <a:lvl9pPr>
+              <a:buNone/>
               <a:defRPr sz="4650" b="1">
                 <a:solidFill>
                   <a:srgbClr val="087F8C"/>
@@ -7289,6 +7378,7 @@
           </a:lstStyle>
           <a:p xmlns:a="http://schemas.openxmlformats.org/drawingml/2006/main">
             <a:pPr>
+              <a:buNone/>
               <a:defRPr sz="4650" b="1">
                 <a:solidFill>
                   <a:srgbClr val="087F8C"/>
@@ -7307,7 +7397,7 @@
                 <a:ea typeface="Malgun Gothic"/>
                 <a:cs typeface="Malgun Gothic"/>
               </a:rPr>
-              <a:t>01  연구 질문과 기여</a:t>
+              <a:t>01  연구 기여와 비교 설계</a:t>
             </a:r>
           </a:p>
         </p:txBody>
@@ -7345,7 +7435,7 @@
           </a:bodyPr>
           <a:lstStyle xmlns:a="http://schemas.openxmlformats.org/drawingml/2006/main">
             <a:defPPr>
-              <a:defRPr sz="4050" b="1">
+              <a:defRPr sz="3750" b="1">
                 <a:solidFill>
                   <a:srgbClr val="132F43"/>
                 </a:solidFill>
@@ -7355,6 +7445,7 @@
               </a:defRPr>
             </a:defPPr>
             <a:lvl1pPr>
+              <a:buNone/>
               <a:defRPr sz="4050" b="1">
                 <a:solidFill>
                   <a:srgbClr val="132F43"/>
@@ -7365,6 +7456,7 @@
               </a:defRPr>
             </a:lvl1pPr>
             <a:lvl2pPr>
+              <a:buNone/>
               <a:defRPr sz="4050" b="1">
                 <a:solidFill>
                   <a:srgbClr val="132F43"/>
@@ -7375,6 +7467,7 @@
               </a:defRPr>
             </a:lvl2pPr>
             <a:lvl3pPr>
+              <a:buNone/>
               <a:defRPr sz="4050" b="1">
                 <a:solidFill>
                   <a:srgbClr val="132F43"/>
@@ -7385,6 +7478,7 @@
               </a:defRPr>
             </a:lvl3pPr>
             <a:lvl4pPr>
+              <a:buNone/>
               <a:defRPr sz="4050" b="1">
                 <a:solidFill>
                   <a:srgbClr val="132F43"/>
@@ -7395,6 +7489,7 @@
               </a:defRPr>
             </a:lvl4pPr>
             <a:lvl5pPr>
+              <a:buNone/>
               <a:defRPr sz="4050" b="1">
                 <a:solidFill>
                   <a:srgbClr val="132F43"/>
@@ -7405,6 +7500,7 @@
               </a:defRPr>
             </a:lvl5pPr>
             <a:lvl6pPr>
+              <a:buNone/>
               <a:defRPr sz="4050" b="1">
                 <a:solidFill>
                   <a:srgbClr val="132F43"/>
@@ -7415,6 +7511,7 @@
               </a:defRPr>
             </a:lvl6pPr>
             <a:lvl7pPr>
+              <a:buNone/>
               <a:defRPr sz="4050" b="1">
                 <a:solidFill>
                   <a:srgbClr val="132F43"/>
@@ -7425,6 +7522,7 @@
               </a:defRPr>
             </a:lvl7pPr>
             <a:lvl8pPr>
+              <a:buNone/>
               <a:defRPr sz="4050" b="1">
                 <a:solidFill>
                   <a:srgbClr val="132F43"/>
@@ -7435,6 +7533,7 @@
               </a:defRPr>
             </a:lvl8pPr>
             <a:lvl9pPr>
+              <a:buNone/>
               <a:defRPr sz="4050" b="1">
                 <a:solidFill>
                   <a:srgbClr val="132F43"/>
@@ -7447,7 +7546,8 @@
           </a:lstStyle>
           <a:p xmlns:a="http://schemas.openxmlformats.org/drawingml/2006/main">
             <a:pPr>
-              <a:defRPr sz="4050" b="1">
+              <a:buNone/>
+              <a:defRPr sz="3750" b="1">
                 <a:solidFill>
                   <a:srgbClr val="132F43"/>
                 </a:solidFill>
@@ -7457,7 +7557,7 @@
               </a:defRPr>
             </a:pPr>
             <a:r>
-              <a:rPr sz="4050" b="1">
+              <a:rPr sz="3750" b="1">
                 <a:solidFill>
                   <a:srgbClr val="132F43"/>
                 </a:solidFill>
@@ -7465,12 +7565,13 @@
                 <a:ea typeface="Malgun Gothic"/>
                 <a:cs typeface="Malgun Gothic"/>
               </a:rPr>
-              <a:t>활동 요약에 필요한 구분 수준이</a:t>
+              <a:t>출력 목표·입력 표현·처리 비용을</a:t>
             </a:r>
           </a:p>
           <a:p xmlns:a="http://schemas.openxmlformats.org/drawingml/2006/main">
             <a:pPr>
-              <a:defRPr sz="4050" b="1">
+              <a:buNone/>
+              <a:defRPr sz="3750" b="1">
                 <a:solidFill>
                   <a:srgbClr val="132F43"/>
                 </a:solidFill>
@@ -7480,7 +7581,7 @@
               </a:defRPr>
             </a:pPr>
             <a:r>
-              <a:rPr sz="4050" b="1">
+              <a:rPr sz="3750" b="1">
                 <a:solidFill>
                   <a:srgbClr val="132F43"/>
                 </a:solidFill>
@@ -7488,7 +7589,7 @@
                 <a:ea typeface="Malgun Gothic"/>
                 <a:cs typeface="Malgun Gothic"/>
               </a:rPr>
-              <a:t>모델 선택을 어떻게 바꾸는가?</a:t>
+              <a:t>사람 독립 평가에서 함께 대조</a:t>
             </a:r>
           </a:p>
         </p:txBody>
@@ -7526,7 +7627,7 @@
           </a:bodyPr>
           <a:lstStyle xmlns:a="http://schemas.openxmlformats.org/drawingml/2006/main">
             <a:defPPr>
-              <a:defRPr sz="3150" b="0">
+              <a:defRPr sz="3000" b="0">
                 <a:solidFill>
                   <a:srgbClr val="132F43"/>
                 </a:solidFill>
@@ -7536,6 +7637,7 @@
               </a:defRPr>
             </a:defPPr>
             <a:lvl1pPr>
+              <a:buNone/>
               <a:defRPr sz="3150" b="0">
                 <a:solidFill>
                   <a:srgbClr val="132F43"/>
@@ -7546,6 +7648,7 @@
               </a:defRPr>
             </a:lvl1pPr>
             <a:lvl2pPr>
+              <a:buNone/>
               <a:defRPr sz="3150" b="0">
                 <a:solidFill>
                   <a:srgbClr val="132F43"/>
@@ -7556,6 +7659,7 @@
               </a:defRPr>
             </a:lvl2pPr>
             <a:lvl3pPr>
+              <a:buNone/>
               <a:defRPr sz="3150" b="0">
                 <a:solidFill>
                   <a:srgbClr val="132F43"/>
@@ -7566,6 +7670,7 @@
               </a:defRPr>
             </a:lvl3pPr>
             <a:lvl4pPr>
+              <a:buNone/>
               <a:defRPr sz="3150" b="0">
                 <a:solidFill>
                   <a:srgbClr val="132F43"/>
@@ -7576,6 +7681,7 @@
               </a:defRPr>
             </a:lvl4pPr>
             <a:lvl5pPr>
+              <a:buNone/>
               <a:defRPr sz="3150" b="0">
                 <a:solidFill>
                   <a:srgbClr val="132F43"/>
@@ -7586,6 +7692,7 @@
               </a:defRPr>
             </a:lvl5pPr>
             <a:lvl6pPr>
+              <a:buNone/>
               <a:defRPr sz="3150" b="0">
                 <a:solidFill>
                   <a:srgbClr val="132F43"/>
@@ -7596,6 +7703,7 @@
               </a:defRPr>
             </a:lvl6pPr>
             <a:lvl7pPr>
+              <a:buNone/>
               <a:defRPr sz="3150" b="0">
                 <a:solidFill>
                   <a:srgbClr val="132F43"/>
@@ -7606,6 +7714,7 @@
               </a:defRPr>
             </a:lvl7pPr>
             <a:lvl8pPr>
+              <a:buNone/>
               <a:defRPr sz="3150" b="0">
                 <a:solidFill>
                   <a:srgbClr val="132F43"/>
@@ -7616,6 +7725,7 @@
               </a:defRPr>
             </a:lvl8pPr>
             <a:lvl9pPr>
+              <a:buNone/>
               <a:defRPr sz="3150" b="0">
                 <a:solidFill>
                   <a:srgbClr val="132F43"/>
@@ -7628,7 +7738,8 @@
           </a:lstStyle>
           <a:p xmlns:a="http://schemas.openxmlformats.org/drawingml/2006/main">
             <a:pPr>
-              <a:defRPr sz="3150" b="0">
+              <a:buNone/>
+              <a:defRPr sz="3000" b="0">
                 <a:solidFill>
                   <a:srgbClr val="132F43"/>
                 </a:solidFill>
@@ -7638,7 +7749,7 @@
               </a:defRPr>
             </a:pPr>
             <a:r>
-              <a:rPr sz="3150" b="0">
+              <a:rPr sz="3000" b="0">
                 <a:solidFill>
                   <a:srgbClr val="132F43"/>
                 </a:solidFill>
@@ -7646,12 +7757,13 @@
                 <a:ea typeface="Malgun Gothic"/>
                 <a:cs typeface="Malgun Gothic"/>
               </a:rPr>
-              <a:t>같은 3상태에서 예측 병합과 직접 학습을 대조했다.</a:t>
+              <a:t>목표: 6종 예측 병합 vs. 3상태 직접 학습</a:t>
             </a:r>
           </a:p>
           <a:p xmlns:a="http://schemas.openxmlformats.org/drawingml/2006/main">
             <a:pPr>
-              <a:defRPr sz="3150" b="0">
+              <a:buNone/>
+              <a:defRPr sz="3000" b="0">
                 <a:solidFill>
                   <a:srgbClr val="132F43"/>
                 </a:solidFill>
@@ -7661,7 +7773,7 @@
               </a:defRPr>
             </a:pPr>
             <a:r>
-              <a:rPr sz="3150" b="0">
+              <a:rPr sz="3000" b="0">
                 <a:solidFill>
                   <a:srgbClr val="132F43"/>
                 </a:solidFill>
@@ -7669,12 +7781,13 @@
                 <a:ea typeface="Malgun Gothic"/>
                 <a:cs typeface="Malgun Gothic"/>
               </a:rPr>
-              <a:t>동일 18개 특징의 로지스틱 회귀(LR)·MLP와</a:t>
+              <a:t>입력: 18개 특징의 로지스틱 회귀(LR3) vs. FMLP3</a:t>
             </a:r>
           </a:p>
           <a:p xmlns:a="http://schemas.openxmlformats.org/drawingml/2006/main">
             <a:pPr>
-              <a:defRPr sz="3150" b="0">
+              <a:buNone/>
+              <a:defRPr sz="3000" b="0">
                 <a:solidFill>
                   <a:srgbClr val="132F43"/>
                 </a:solidFill>
@@ -7684,7 +7797,7 @@
               </a:defRPr>
             </a:pPr>
             <a:r>
-              <a:rPr sz="3150" b="0">
+              <a:rPr sz="3000" b="0">
                 <a:solidFill>
                   <a:srgbClr val="132F43"/>
                 </a:solidFill>
@@ -7692,7 +7805,7 @@
                 <a:ea typeface="Malgun Gothic"/>
                 <a:cs typeface="Malgun Gothic"/>
               </a:rPr>
-              <a:t>시계열 모델을 사람 독립 test·처리 비용으로 비교했다.</a:t>
+              <a:t>비용: 같은 CPU의 전처리·분류·반환 시간</a:t>
             </a:r>
           </a:p>
         </p:txBody>
@@ -7702,7 +7815,7 @@
           <p:cNvPr id="9" name="">
             <a:extLst xmlns:a="http://schemas.openxmlformats.org/drawingml/2006/main">
               <a:ext uri="{FF2B5EF4-FFF2-40B4-BE49-F238E27FC236}">
-                <a16:creationId xmlns:a16="http://schemas.microsoft.com/office/drawing/2014/main" id="{1CD2CC06-197B-4D09-9EFD-1E340473B403}"/>
+                <a16:creationId xmlns:a16="http://schemas.microsoft.com/office/drawing/2014/main" id="{84FC0516-1B21-4A1D-B1DE-1F1DCD50A1C7}"/>
               </a:ext>
             </a:extLst>
           </p:cNvPr>
@@ -8100,6 +8213,7 @@
               </a:defRPr>
             </a:defPPr>
             <a:lvl1pPr>
+              <a:buNone/>
               <a:defRPr sz="4650" b="1">
                 <a:solidFill>
                   <a:srgbClr val="087F8C"/>
@@ -8110,6 +8224,7 @@
               </a:defRPr>
             </a:lvl1pPr>
             <a:lvl2pPr>
+              <a:buNone/>
               <a:defRPr sz="4650" b="1">
                 <a:solidFill>
                   <a:srgbClr val="087F8C"/>
@@ -8120,6 +8235,7 @@
               </a:defRPr>
             </a:lvl2pPr>
             <a:lvl3pPr>
+              <a:buNone/>
               <a:defRPr sz="4650" b="1">
                 <a:solidFill>
                   <a:srgbClr val="087F8C"/>
@@ -8130,6 +8246,7 @@
               </a:defRPr>
             </a:lvl3pPr>
             <a:lvl4pPr>
+              <a:buNone/>
               <a:defRPr sz="4650" b="1">
                 <a:solidFill>
                   <a:srgbClr val="087F8C"/>
@@ -8140,6 +8257,7 @@
               </a:defRPr>
             </a:lvl4pPr>
             <a:lvl5pPr>
+              <a:buNone/>
               <a:defRPr sz="4650" b="1">
                 <a:solidFill>
                   <a:srgbClr val="087F8C"/>
@@ -8150,6 +8268,7 @@
               </a:defRPr>
             </a:lvl5pPr>
             <a:lvl6pPr>
+              <a:buNone/>
               <a:defRPr sz="4650" b="1">
                 <a:solidFill>
                   <a:srgbClr val="087F8C"/>
@@ -8160,6 +8279,7 @@
               </a:defRPr>
             </a:lvl6pPr>
             <a:lvl7pPr>
+              <a:buNone/>
               <a:defRPr sz="4650" b="1">
                 <a:solidFill>
                   <a:srgbClr val="087F8C"/>
@@ -8170,6 +8290,7 @@
               </a:defRPr>
             </a:lvl7pPr>
             <a:lvl8pPr>
+              <a:buNone/>
               <a:defRPr sz="4650" b="1">
                 <a:solidFill>
                   <a:srgbClr val="087F8C"/>
@@ -8180,6 +8301,7 @@
               </a:defRPr>
             </a:lvl8pPr>
             <a:lvl9pPr>
+              <a:buNone/>
               <a:defRPr sz="4650" b="1">
                 <a:solidFill>
                   <a:srgbClr val="087F8C"/>
@@ -8192,6 +8314,7 @@
           </a:lstStyle>
           <a:p xmlns:a="http://schemas.openxmlformats.org/drawingml/2006/main">
             <a:pPr>
+              <a:buNone/>
               <a:defRPr sz="4650" b="1">
                 <a:solidFill>
                   <a:srgbClr val="087F8C"/>
@@ -8232,7 +8355,7 @@
         <p:spPr>
           <a:xfrm xmlns:a="http://schemas.openxmlformats.org/drawingml/2006/main">
             <a:off x="15716250" y="10553700"/>
-            <a:ext cx="13321500" cy="1333500"/>
+            <a:ext cx="13321475" cy="1466850"/>
           </a:xfrm>
           <a:prstGeom xmlns:a="http://schemas.openxmlformats.org/drawingml/2006/main" prst="rect">
             <a:avLst/>
@@ -8248,7 +8371,7 @@
           </a:bodyPr>
           <a:lstStyle xmlns:a="http://schemas.openxmlformats.org/drawingml/2006/main">
             <a:defPPr>
-              <a:defRPr sz="3375" b="0">
+              <a:defRPr sz="2925" b="0">
                 <a:solidFill>
                   <a:srgbClr val="132F43"/>
                 </a:solidFill>
@@ -8258,6 +8381,7 @@
               </a:defRPr>
             </a:defPPr>
             <a:lvl1pPr>
+              <a:buNone/>
               <a:defRPr sz="3375" b="0">
                 <a:solidFill>
                   <a:srgbClr val="132F43"/>
@@ -8268,6 +8392,7 @@
               </a:defRPr>
             </a:lvl1pPr>
             <a:lvl2pPr>
+              <a:buNone/>
               <a:defRPr sz="3375" b="0">
                 <a:solidFill>
                   <a:srgbClr val="132F43"/>
@@ -8278,6 +8403,7 @@
               </a:defRPr>
             </a:lvl2pPr>
             <a:lvl3pPr>
+              <a:buNone/>
               <a:defRPr sz="3375" b="0">
                 <a:solidFill>
                   <a:srgbClr val="132F43"/>
@@ -8288,6 +8414,7 @@
               </a:defRPr>
             </a:lvl3pPr>
             <a:lvl4pPr>
+              <a:buNone/>
               <a:defRPr sz="3375" b="0">
                 <a:solidFill>
                   <a:srgbClr val="132F43"/>
@@ -8298,6 +8425,7 @@
               </a:defRPr>
             </a:lvl4pPr>
             <a:lvl5pPr>
+              <a:buNone/>
               <a:defRPr sz="3375" b="0">
                 <a:solidFill>
                   <a:srgbClr val="132F43"/>
@@ -8308,6 +8436,7 @@
               </a:defRPr>
             </a:lvl5pPr>
             <a:lvl6pPr>
+              <a:buNone/>
               <a:defRPr sz="3375" b="0">
                 <a:solidFill>
                   <a:srgbClr val="132F43"/>
@@ -8318,6 +8447,7 @@
               </a:defRPr>
             </a:lvl6pPr>
             <a:lvl7pPr>
+              <a:buNone/>
               <a:defRPr sz="3375" b="0">
                 <a:solidFill>
                   <a:srgbClr val="132F43"/>
@@ -8328,6 +8458,7 @@
               </a:defRPr>
             </a:lvl7pPr>
             <a:lvl8pPr>
+              <a:buNone/>
               <a:defRPr sz="3375" b="0">
                 <a:solidFill>
                   <a:srgbClr val="132F43"/>
@@ -8338,6 +8469,7 @@
               </a:defRPr>
             </a:lvl8pPr>
             <a:lvl9pPr>
+              <a:buNone/>
               <a:defRPr sz="3375" b="0">
                 <a:solidFill>
                   <a:srgbClr val="132F43"/>
@@ -8350,7 +8482,8 @@
           </a:lstStyle>
           <a:p xmlns:a="http://schemas.openxmlformats.org/drawingml/2006/main">
             <a:pPr>
-              <a:defRPr sz="3375" b="0">
+              <a:buNone/>
+              <a:defRPr sz="2925" b="0">
                 <a:solidFill>
                   <a:srgbClr val="132F43"/>
                 </a:solidFill>
@@ -8360,7 +8493,7 @@
               </a:defRPr>
             </a:pPr>
             <a:r>
-              <a:rPr sz="3375" b="0">
+              <a:rPr sz="2925" b="0">
                 <a:solidFill>
                   <a:srgbClr val="132F43"/>
                 </a:solidFill>
@@ -8368,12 +8501,13 @@
                 <a:ea typeface="Malgun Gothic"/>
                 <a:cs typeface="Malgun Gothic"/>
               </a:rPr>
-              <a:t>UCI HAR [1] · 허리 착용 · 가속도·각속도</a:t>
+              <a:t>UCI HAR [1] · 허리 착용 스마트폰</a:t>
             </a:r>
           </a:p>
           <a:p xmlns:a="http://schemas.openxmlformats.org/drawingml/2006/main">
             <a:pPr>
-              <a:defRPr sz="3375" b="0">
+              <a:buNone/>
+              <a:defRPr sz="2925" b="0">
                 <a:solidFill>
                   <a:srgbClr val="132F43"/>
                 </a:solidFill>
@@ -8383,7 +8517,7 @@
               </a:defRPr>
             </a:pPr>
             <a:r>
-              <a:rPr sz="3375" b="0">
+              <a:rPr sz="2925" b="0">
                 <a:solidFill>
                   <a:srgbClr val="132F43"/>
                 </a:solidFill>
@@ -8391,7 +8525,31 @@
                 <a:ea typeface="Malgun Gothic"/>
                 <a:cs typeface="Malgun Gothic"/>
               </a:rPr>
-              <a:t>9채널 × 128시점 · 50Hz · 2.56초 · 50% 중첩</a:t>
+              <a:t>신체·총 가속도·각속도, 각 3축: 9채널</a:t>
+            </a:r>
+          </a:p>
+          <a:p xmlns:a="http://schemas.openxmlformats.org/drawingml/2006/main">
+            <a:pPr>
+              <a:buNone/>
+              <a:defRPr sz="2925" b="0">
+                <a:solidFill>
+                  <a:srgbClr val="132F43"/>
+                </a:solidFill>
+                <a:latin typeface="Malgun Gothic"/>
+                <a:ea typeface="Malgun Gothic"/>
+                <a:cs typeface="Malgun Gothic"/>
+              </a:defRPr>
+            </a:pPr>
+            <a:r>
+              <a:rPr sz="2925" b="0">
+                <a:solidFill>
+                  <a:srgbClr val="132F43"/>
+                </a:solidFill>
+                <a:latin typeface="Malgun Gothic"/>
+                <a:ea typeface="Malgun Gothic"/>
+                <a:cs typeface="Malgun Gothic"/>
+              </a:rPr>
+              <a:t>128시점 · 50Hz · 2.56초 · 50% 중첩</a:t>
             </a:r>
           </a:p>
         </p:txBody>
@@ -8401,7 +8559,7 @@
           <p:cNvPr id="12" name="">
             <a:extLst xmlns:a="http://schemas.openxmlformats.org/drawingml/2006/main">
               <a:ext uri="{FF2B5EF4-FFF2-40B4-BE49-F238E27FC236}">
-                <a16:creationId xmlns:a16="http://schemas.microsoft.com/office/drawing/2014/main" id="{128D594E-8517-4879-931A-7DF2368CFDAA}"/>
+                <a16:creationId xmlns:a16="http://schemas.microsoft.com/office/drawing/2014/main" id="{761AFCE2-E15E-4006-8A30-02D8DCE6AFD2}"/>
               </a:ext>
             </a:extLst>
           </p:cNvPr>
@@ -8950,6 +9108,7 @@
               </a:defRPr>
             </a:defPPr>
             <a:lvl1pPr>
+              <a:buNone/>
               <a:defRPr sz="3375" b="0">
                 <a:solidFill>
                   <a:srgbClr val="132F43"/>
@@ -8960,6 +9119,7 @@
               </a:defRPr>
             </a:lvl1pPr>
             <a:lvl2pPr>
+              <a:buNone/>
               <a:defRPr sz="3375" b="0">
                 <a:solidFill>
                   <a:srgbClr val="132F43"/>
@@ -8970,6 +9130,7 @@
               </a:defRPr>
             </a:lvl2pPr>
             <a:lvl3pPr>
+              <a:buNone/>
               <a:defRPr sz="3375" b="0">
                 <a:solidFill>
                   <a:srgbClr val="132F43"/>
@@ -8980,6 +9141,7 @@
               </a:defRPr>
             </a:lvl3pPr>
             <a:lvl4pPr>
+              <a:buNone/>
               <a:defRPr sz="3375" b="0">
                 <a:solidFill>
                   <a:srgbClr val="132F43"/>
@@ -8990,6 +9152,7 @@
               </a:defRPr>
             </a:lvl4pPr>
             <a:lvl5pPr>
+              <a:buNone/>
               <a:defRPr sz="3375" b="0">
                 <a:solidFill>
                   <a:srgbClr val="132F43"/>
@@ -9000,6 +9163,7 @@
               </a:defRPr>
             </a:lvl5pPr>
             <a:lvl6pPr>
+              <a:buNone/>
               <a:defRPr sz="3375" b="0">
                 <a:solidFill>
                   <a:srgbClr val="132F43"/>
@@ -9010,6 +9174,7 @@
               </a:defRPr>
             </a:lvl6pPr>
             <a:lvl7pPr>
+              <a:buNone/>
               <a:defRPr sz="3375" b="0">
                 <a:solidFill>
                   <a:srgbClr val="132F43"/>
@@ -9020,6 +9185,7 @@
               </a:defRPr>
             </a:lvl7pPr>
             <a:lvl8pPr>
+              <a:buNone/>
               <a:defRPr sz="3375" b="0">
                 <a:solidFill>
                   <a:srgbClr val="132F43"/>
@@ -9030,6 +9196,7 @@
               </a:defRPr>
             </a:lvl8pPr>
             <a:lvl9pPr>
+              <a:buNone/>
               <a:defRPr sz="3375" b="0">
                 <a:solidFill>
                   <a:srgbClr val="132F43"/>
@@ -9042,6 +9209,7 @@
           </a:lstStyle>
           <a:p xmlns:a="http://schemas.openxmlformats.org/drawingml/2006/main">
             <a:pPr>
+              <a:buNone/>
               <a:defRPr sz="3375" b="0">
                 <a:solidFill>
                   <a:srgbClr val="132F43"/>
@@ -9065,6 +9233,7 @@
           </a:p>
           <a:p xmlns:a="http://schemas.openxmlformats.org/drawingml/2006/main">
             <a:pPr>
+              <a:buNone/>
               <a:defRPr sz="3375" b="0">
                 <a:solidFill>
                   <a:srgbClr val="132F43"/>
@@ -9105,7 +9274,7 @@
         <p:spPr>
           <a:xfrm xmlns:a="http://schemas.openxmlformats.org/drawingml/2006/main">
             <a:off x="15716250" y="17145000"/>
-            <a:ext cx="13321500" cy="1095375"/>
+            <a:ext cx="13321475" cy="1428750"/>
           </a:xfrm>
           <a:prstGeom xmlns:a="http://schemas.openxmlformats.org/drawingml/2006/main" prst="rect">
             <a:avLst/>
@@ -9121,7 +9290,7 @@
           </a:bodyPr>
           <a:lstStyle xmlns:a="http://schemas.openxmlformats.org/drawingml/2006/main">
             <a:defPPr>
-              <a:defRPr sz="2700" b="0">
+              <a:defRPr sz="2550" b="0">
                 <a:solidFill>
                   <a:srgbClr val="4C606E"/>
                 </a:solidFill>
@@ -9131,6 +9300,7 @@
               </a:defRPr>
             </a:defPPr>
             <a:lvl1pPr>
+              <a:buNone/>
               <a:defRPr sz="2700" b="0">
                 <a:solidFill>
                   <a:srgbClr val="4C606E"/>
@@ -9141,6 +9311,7 @@
               </a:defRPr>
             </a:lvl1pPr>
             <a:lvl2pPr>
+              <a:buNone/>
               <a:defRPr sz="2700" b="0">
                 <a:solidFill>
                   <a:srgbClr val="4C606E"/>
@@ -9151,6 +9322,7 @@
               </a:defRPr>
             </a:lvl2pPr>
             <a:lvl3pPr>
+              <a:buNone/>
               <a:defRPr sz="2700" b="0">
                 <a:solidFill>
                   <a:srgbClr val="4C606E"/>
@@ -9161,6 +9333,7 @@
               </a:defRPr>
             </a:lvl3pPr>
             <a:lvl4pPr>
+              <a:buNone/>
               <a:defRPr sz="2700" b="0">
                 <a:solidFill>
                   <a:srgbClr val="4C606E"/>
@@ -9171,6 +9344,7 @@
               </a:defRPr>
             </a:lvl4pPr>
             <a:lvl5pPr>
+              <a:buNone/>
               <a:defRPr sz="2700" b="0">
                 <a:solidFill>
                   <a:srgbClr val="4C606E"/>
@@ -9181,6 +9355,7 @@
               </a:defRPr>
             </a:lvl5pPr>
             <a:lvl6pPr>
+              <a:buNone/>
               <a:defRPr sz="2700" b="0">
                 <a:solidFill>
                   <a:srgbClr val="4C606E"/>
@@ -9191,6 +9366,7 @@
               </a:defRPr>
             </a:lvl6pPr>
             <a:lvl7pPr>
+              <a:buNone/>
               <a:defRPr sz="2700" b="0">
                 <a:solidFill>
                   <a:srgbClr val="4C606E"/>
@@ -9201,6 +9377,7 @@
               </a:defRPr>
             </a:lvl7pPr>
             <a:lvl8pPr>
+              <a:buNone/>
               <a:defRPr sz="2700" b="0">
                 <a:solidFill>
                   <a:srgbClr val="4C606E"/>
@@ -9211,6 +9388,7 @@
               </a:defRPr>
             </a:lvl8pPr>
             <a:lvl9pPr>
+              <a:buNone/>
               <a:defRPr sz="2700" b="0">
                 <a:solidFill>
                   <a:srgbClr val="4C606E"/>
@@ -9223,7 +9401,8 @@
           </a:lstStyle>
           <a:p xmlns:a="http://schemas.openxmlformats.org/drawingml/2006/main">
             <a:pPr>
-              <a:defRPr sz="2700" b="0">
+              <a:buNone/>
+              <a:defRPr sz="2550" b="0">
                 <a:solidFill>
                   <a:srgbClr val="4C606E"/>
                 </a:solidFill>
@@ -9233,7 +9412,7 @@
               </a:defRPr>
             </a:pPr>
             <a:r>
-              <a:rPr sz="2700" b="0">
+              <a:rPr sz="2550" b="0">
                 <a:solidFill>
                   <a:srgbClr val="4C606E"/>
                 </a:solidFill>
@@ -9241,12 +9420,13 @@
                 <a:ea typeface="Malgun Gothic"/>
                 <a:cs typeface="Malgun Gothic"/>
               </a:rPr>
-              <a:t>NN: seed 2026·2027·2028, Adam 0.001, batch 64,</a:t>
+              <a:t>신경망: seed 2026·2027·2028, Adam 0.001, batch 64,</a:t>
             </a:r>
           </a:p>
           <a:p xmlns:a="http://schemas.openxmlformats.org/drawingml/2006/main">
             <a:pPr>
-              <a:defRPr sz="2700" b="0">
+              <a:buNone/>
+              <a:defRPr sz="2550" b="0">
                 <a:solidFill>
                   <a:srgbClr val="4C606E"/>
                 </a:solidFill>
@@ -9256,7 +9436,7 @@
               </a:defRPr>
             </a:pPr>
             <a:r>
-              <a:rPr sz="2700" b="0">
+              <a:rPr sz="2550" b="0">
                 <a:solidFill>
                   <a:srgbClr val="4C606E"/>
                 </a:solidFill>
@@ -9265,6 +9445,30 @@
                 <a:cs typeface="Malgun Gothic"/>
               </a:rPr>
               <a:t>최대 40 epoch, 검증 손실 patience 6·최선 가중치 복원</a:t>
+            </a:r>
+          </a:p>
+          <a:p xmlns:a="http://schemas.openxmlformats.org/drawingml/2006/main">
+            <a:pPr>
+              <a:buNone/>
+              <a:defRPr sz="2550" b="0">
+                <a:solidFill>
+                  <a:srgbClr val="4C606E"/>
+                </a:solidFill>
+                <a:latin typeface="Malgun Gothic"/>
+                <a:ea typeface="Malgun Gothic"/>
+                <a:cs typeface="Malgun Gothic"/>
+              </a:defRPr>
+            </a:pPr>
+            <a:r>
+              <a:rPr sz="2550" b="0">
+                <a:solidFill>
+                  <a:srgbClr val="4C606E"/>
+                </a:solidFill>
+                <a:latin typeface="Malgun Gothic"/>
+                <a:ea typeface="Malgun Gothic"/>
+                <a:cs typeface="Malgun Gothic"/>
+              </a:rPr>
+              <a:t>입력: 시계열 4종 128×9 / LR·FMLP 18개 특징</a:t>
             </a:r>
           </a:p>
         </p:txBody>
@@ -9312,6 +9516,7 @@
               </a:defRPr>
             </a:defPPr>
             <a:lvl1pPr>
+              <a:buNone/>
               <a:defRPr sz="4650" b="1">
                 <a:solidFill>
                   <a:srgbClr val="087F8C"/>
@@ -9322,6 +9527,7 @@
               </a:defRPr>
             </a:lvl1pPr>
             <a:lvl2pPr>
+              <a:buNone/>
               <a:defRPr sz="4650" b="1">
                 <a:solidFill>
                   <a:srgbClr val="087F8C"/>
@@ -9332,6 +9538,7 @@
               </a:defRPr>
             </a:lvl2pPr>
             <a:lvl3pPr>
+              <a:buNone/>
               <a:defRPr sz="4650" b="1">
                 <a:solidFill>
                   <a:srgbClr val="087F8C"/>
@@ -9342,6 +9549,7 @@
               </a:defRPr>
             </a:lvl3pPr>
             <a:lvl4pPr>
+              <a:buNone/>
               <a:defRPr sz="4650" b="1">
                 <a:solidFill>
                   <a:srgbClr val="087F8C"/>
@@ -9352,6 +9560,7 @@
               </a:defRPr>
             </a:lvl4pPr>
             <a:lvl5pPr>
+              <a:buNone/>
               <a:defRPr sz="4650" b="1">
                 <a:solidFill>
                   <a:srgbClr val="087F8C"/>
@@ -9362,6 +9571,7 @@
               </a:defRPr>
             </a:lvl5pPr>
             <a:lvl6pPr>
+              <a:buNone/>
               <a:defRPr sz="4650" b="1">
                 <a:solidFill>
                   <a:srgbClr val="087F8C"/>
@@ -9372,6 +9582,7 @@
               </a:defRPr>
             </a:lvl6pPr>
             <a:lvl7pPr>
+              <a:buNone/>
               <a:defRPr sz="4650" b="1">
                 <a:solidFill>
                   <a:srgbClr val="087F8C"/>
@@ -9382,6 +9593,7 @@
               </a:defRPr>
             </a:lvl7pPr>
             <a:lvl8pPr>
+              <a:buNone/>
               <a:defRPr sz="4650" b="1">
                 <a:solidFill>
                   <a:srgbClr val="087F8C"/>
@@ -9392,6 +9604,7 @@
               </a:defRPr>
             </a:lvl8pPr>
             <a:lvl9pPr>
+              <a:buNone/>
               <a:defRPr sz="4650" b="1">
                 <a:solidFill>
                   <a:srgbClr val="087F8C"/>
@@ -9404,6 +9617,7 @@
           </a:lstStyle>
           <a:p xmlns:a="http://schemas.openxmlformats.org/drawingml/2006/main">
             <a:pPr>
+              <a:buNone/>
               <a:defRPr sz="4650" b="1">
                 <a:solidFill>
                   <a:srgbClr val="087F8C"/>
@@ -9460,7 +9674,7 @@
           </a:bodyPr>
           <a:lstStyle xmlns:a="http://schemas.openxmlformats.org/drawingml/2006/main">
             <a:defPPr>
-              <a:defRPr sz="3825" b="1">
+              <a:defRPr sz="3225" b="1">
                 <a:solidFill>
                   <a:srgbClr val="132F43"/>
                 </a:solidFill>
@@ -9470,6 +9684,7 @@
               </a:defRPr>
             </a:defPPr>
             <a:lvl1pPr>
+              <a:buNone/>
               <a:defRPr sz="3825" b="1">
                 <a:solidFill>
                   <a:srgbClr val="132F43"/>
@@ -9480,6 +9695,7 @@
               </a:defRPr>
             </a:lvl1pPr>
             <a:lvl2pPr>
+              <a:buNone/>
               <a:defRPr sz="3825" b="1">
                 <a:solidFill>
                   <a:srgbClr val="132F43"/>
@@ -9490,6 +9706,7 @@
               </a:defRPr>
             </a:lvl2pPr>
             <a:lvl3pPr>
+              <a:buNone/>
               <a:defRPr sz="3825" b="1">
                 <a:solidFill>
                   <a:srgbClr val="132F43"/>
@@ -9500,6 +9717,7 @@
               </a:defRPr>
             </a:lvl3pPr>
             <a:lvl4pPr>
+              <a:buNone/>
               <a:defRPr sz="3825" b="1">
                 <a:solidFill>
                   <a:srgbClr val="132F43"/>
@@ -9510,6 +9728,7 @@
               </a:defRPr>
             </a:lvl4pPr>
             <a:lvl5pPr>
+              <a:buNone/>
               <a:defRPr sz="3825" b="1">
                 <a:solidFill>
                   <a:srgbClr val="132F43"/>
@@ -9520,6 +9739,7 @@
               </a:defRPr>
             </a:lvl5pPr>
             <a:lvl6pPr>
+              <a:buNone/>
               <a:defRPr sz="3825" b="1">
                 <a:solidFill>
                   <a:srgbClr val="132F43"/>
@@ -9530,6 +9750,7 @@
               </a:defRPr>
             </a:lvl6pPr>
             <a:lvl7pPr>
+              <a:buNone/>
               <a:defRPr sz="3825" b="1">
                 <a:solidFill>
                   <a:srgbClr val="132F43"/>
@@ -9540,6 +9761,7 @@
               </a:defRPr>
             </a:lvl7pPr>
             <a:lvl8pPr>
+              <a:buNone/>
               <a:defRPr sz="3825" b="1">
                 <a:solidFill>
                   <a:srgbClr val="132F43"/>
@@ -9550,6 +9772,7 @@
               </a:defRPr>
             </a:lvl8pPr>
             <a:lvl9pPr>
+              <a:buNone/>
               <a:defRPr sz="3825" b="1">
                 <a:solidFill>
                   <a:srgbClr val="132F43"/>
@@ -9562,7 +9785,8 @@
           </a:lstStyle>
           <a:p xmlns:a="http://schemas.openxmlformats.org/drawingml/2006/main">
             <a:pPr>
-              <a:defRPr sz="3825" b="1">
+              <a:buNone/>
+              <a:defRPr sz="3225" b="1">
                 <a:solidFill>
                   <a:srgbClr val="132F43"/>
                 </a:solidFill>
@@ -9572,7 +9796,7 @@
               </a:defRPr>
             </a:pPr>
             <a:r>
-              <a:rPr sz="3825" b="1">
+              <a:rPr sz="3225" b="1">
                 <a:solidFill>
                   <a:srgbClr val="132F43"/>
                 </a:solidFill>
@@ -9580,7 +9804,7 @@
                 <a:ea typeface="Malgun Gothic"/>
                 <a:cs typeface="Malgun Gothic"/>
               </a:rPr>
-              <a:t>공식 test Macro F1</a:t>
+              <a:t>공식 test Macro F1 (클래스별 F1 평균)</a:t>
             </a:r>
           </a:p>
         </p:txBody>
@@ -9590,7 +9814,7 @@
           <p:cNvPr id="17" name="">
             <a:extLst xmlns:a="http://schemas.openxmlformats.org/drawingml/2006/main">
               <a:ext uri="{FF2B5EF4-FFF2-40B4-BE49-F238E27FC236}">
-                <a16:creationId xmlns:a16="http://schemas.microsoft.com/office/drawing/2014/main" id="{6191E9F8-9983-4708-8B18-38C98339B4A3}"/>
+                <a16:creationId xmlns:a16="http://schemas.microsoft.com/office/drawing/2014/main" id="{77A865F7-F020-4FC6-8AB5-089DF7B7EAB2}"/>
               </a:ext>
             </a:extLst>
           </p:cNvPr>
@@ -10736,7 +10960,7 @@
           </a:bodyPr>
           <a:lstStyle xmlns:a="http://schemas.openxmlformats.org/drawingml/2006/main">
             <a:defPPr>
-              <a:defRPr sz="2550" b="0">
+              <a:defRPr sz="2475" b="0">
                 <a:solidFill>
                   <a:srgbClr val="4C606E"/>
                 </a:solidFill>
@@ -10746,6 +10970,7 @@
               </a:defRPr>
             </a:defPPr>
             <a:lvl1pPr>
+              <a:buNone/>
               <a:defRPr sz="2550" b="0">
                 <a:solidFill>
                   <a:srgbClr val="4C606E"/>
@@ -10756,6 +10981,7 @@
               </a:defRPr>
             </a:lvl1pPr>
             <a:lvl2pPr>
+              <a:buNone/>
               <a:defRPr sz="2550" b="0">
                 <a:solidFill>
                   <a:srgbClr val="4C606E"/>
@@ -10766,6 +10992,7 @@
               </a:defRPr>
             </a:lvl2pPr>
             <a:lvl3pPr>
+              <a:buNone/>
               <a:defRPr sz="2550" b="0">
                 <a:solidFill>
                   <a:srgbClr val="4C606E"/>
@@ -10776,6 +11003,7 @@
               </a:defRPr>
             </a:lvl3pPr>
             <a:lvl4pPr>
+              <a:buNone/>
               <a:defRPr sz="2550" b="0">
                 <a:solidFill>
                   <a:srgbClr val="4C606E"/>
@@ -10786,6 +11014,7 @@
               </a:defRPr>
             </a:lvl4pPr>
             <a:lvl5pPr>
+              <a:buNone/>
               <a:defRPr sz="2550" b="0">
                 <a:solidFill>
                   <a:srgbClr val="4C606E"/>
@@ -10796,6 +11025,7 @@
               </a:defRPr>
             </a:lvl5pPr>
             <a:lvl6pPr>
+              <a:buNone/>
               <a:defRPr sz="2550" b="0">
                 <a:solidFill>
                   <a:srgbClr val="4C606E"/>
@@ -10806,6 +11036,7 @@
               </a:defRPr>
             </a:lvl6pPr>
             <a:lvl7pPr>
+              <a:buNone/>
               <a:defRPr sz="2550" b="0">
                 <a:solidFill>
                   <a:srgbClr val="4C606E"/>
@@ -10816,6 +11047,7 @@
               </a:defRPr>
             </a:lvl7pPr>
             <a:lvl8pPr>
+              <a:buNone/>
               <a:defRPr sz="2550" b="0">
                 <a:solidFill>
                   <a:srgbClr val="4C606E"/>
@@ -10826,6 +11058,7 @@
               </a:defRPr>
             </a:lvl8pPr>
             <a:lvl9pPr>
+              <a:buNone/>
               <a:defRPr sz="2550" b="0">
                 <a:solidFill>
                   <a:srgbClr val="4C606E"/>
@@ -10838,7 +11071,8 @@
           </a:lstStyle>
           <a:p xmlns:a="http://schemas.openxmlformats.org/drawingml/2006/main">
             <a:pPr>
-              <a:defRPr sz="2550" b="0">
+              <a:buNone/>
+              <a:defRPr sz="2475" b="0">
                 <a:solidFill>
                   <a:srgbClr val="4C606E"/>
                 </a:solidFill>
@@ -10848,7 +11082,7 @@
               </a:defRPr>
             </a:pPr>
             <a:r>
-              <a:rPr sz="2550" b="0">
+              <a:rPr sz="2475" b="0">
                 <a:solidFill>
                   <a:srgbClr val="4C606E"/>
                 </a:solidFill>
@@ -10856,12 +11090,13 @@
                 <a:ea typeface="Malgun Gothic"/>
                 <a:cs typeface="Malgun Gothic"/>
               </a:rPr>
-              <a:t>NN은 3 seed 평균±표본 SD, LR은 단일 학습.</a:t>
+              <a:t>신경망: 3 seed 평균±표본 SD / LR: 단일 학습.</a:t>
             </a:r>
           </a:p>
           <a:p xmlns:a="http://schemas.openxmlformats.org/drawingml/2006/main">
             <a:pPr>
-              <a:defRPr sz="2550" b="0">
+              <a:buNone/>
+              <a:defRPr sz="2475" b="0">
                 <a:solidFill>
                   <a:srgbClr val="4C606E"/>
                 </a:solidFill>
@@ -10871,7 +11106,7 @@
               </a:defRPr>
             </a:pPr>
             <a:r>
-              <a:rPr sz="2550" b="0">
+              <a:rPr sz="2475" b="0">
                 <a:solidFill>
                   <a:srgbClr val="4C606E"/>
                 </a:solidFill>
@@ -10879,12 +11114,13 @@
                 <a:ea typeface="Malgun Gothic"/>
                 <a:cs typeface="Malgun Gothic"/>
               </a:rPr>
-              <a:t>6종→3: 6종 argmax 예측을 3상태로 병합.</a:t>
+              <a:t>SD는 학습 변동이며 사람 모집단의 신뢰구간과 구분한다.</a:t>
             </a:r>
           </a:p>
           <a:p xmlns:a="http://schemas.openxmlformats.org/drawingml/2006/main">
             <a:pPr>
-              <a:defRPr sz="2550" b="0">
+              <a:buNone/>
+              <a:defRPr sz="2475" b="0">
                 <a:solidFill>
                   <a:srgbClr val="4C606E"/>
                 </a:solidFill>
@@ -10894,7 +11130,7 @@
               </a:defRPr>
             </a:pPr>
             <a:r>
-              <a:rPr sz="2550" b="0">
+              <a:rPr sz="2475" b="0">
                 <a:solidFill>
                   <a:srgbClr val="4C606E"/>
                 </a:solidFill>
@@ -10902,12 +11138,13 @@
                 <a:ea typeface="Malgun Gothic"/>
                 <a:cs typeface="Malgun Gothic"/>
               </a:rPr>
-              <a:t>FMLP: 18개 통계 특징을 입력으로 사용한 MLP.</a:t>
+              <a:t>6종→3: 6종 argmax 후 병합. 6종·3상태는 별도 과제.</a:t>
             </a:r>
           </a:p>
           <a:p xmlns:a="http://schemas.openxmlformats.org/drawingml/2006/main">
             <a:pPr>
-              <a:defRPr sz="2550" b="0">
+              <a:buNone/>
+              <a:defRPr sz="2475" b="0">
                 <a:solidFill>
                   <a:srgbClr val="4C606E"/>
                 </a:solidFill>
@@ -10917,7 +11154,7 @@
               </a:defRPr>
             </a:pPr>
             <a:r>
-              <a:rPr sz="2550" b="0">
+              <a:rPr sz="2475" b="0">
                 <a:solidFill>
                   <a:srgbClr val="4C606E"/>
                 </a:solidFill>
@@ -10925,7 +11162,7 @@
                 <a:ea typeface="Malgun Gothic"/>
                 <a:cs typeface="Malgun Gothic"/>
               </a:rPr>
-              <a:t>6종과 3상태는 서로 다른 분류 과제이다.</a:t>
+              <a:t>FMLP는 18특징 MLP로, 시계열 MLP와 입력이 다르다.</a:t>
             </a:r>
           </a:p>
         </p:txBody>
@@ -10973,6 +11210,7 @@
               </a:defRPr>
             </a:defPPr>
             <a:lvl1pPr>
+              <a:buNone/>
               <a:defRPr sz="4350" b="1">
                 <a:solidFill>
                   <a:srgbClr val="087F8C"/>
@@ -10983,6 +11221,7 @@
               </a:defRPr>
             </a:lvl1pPr>
             <a:lvl2pPr>
+              <a:buNone/>
               <a:defRPr sz="4350" b="1">
                 <a:solidFill>
                   <a:srgbClr val="087F8C"/>
@@ -10993,6 +11232,7 @@
               </a:defRPr>
             </a:lvl2pPr>
             <a:lvl3pPr>
+              <a:buNone/>
               <a:defRPr sz="4350" b="1">
                 <a:solidFill>
                   <a:srgbClr val="087F8C"/>
@@ -11003,6 +11243,7 @@
               </a:defRPr>
             </a:lvl3pPr>
             <a:lvl4pPr>
+              <a:buNone/>
               <a:defRPr sz="4350" b="1">
                 <a:solidFill>
                   <a:srgbClr val="087F8C"/>
@@ -11013,6 +11254,7 @@
               </a:defRPr>
             </a:lvl4pPr>
             <a:lvl5pPr>
+              <a:buNone/>
               <a:defRPr sz="4350" b="1">
                 <a:solidFill>
                   <a:srgbClr val="087F8C"/>
@@ -11023,6 +11265,7 @@
               </a:defRPr>
             </a:lvl5pPr>
             <a:lvl6pPr>
+              <a:buNone/>
               <a:defRPr sz="4350" b="1">
                 <a:solidFill>
                   <a:srgbClr val="087F8C"/>
@@ -11033,6 +11276,7 @@
               </a:defRPr>
             </a:lvl6pPr>
             <a:lvl7pPr>
+              <a:buNone/>
               <a:defRPr sz="4350" b="1">
                 <a:solidFill>
                   <a:srgbClr val="087F8C"/>
@@ -11043,6 +11287,7 @@
               </a:defRPr>
             </a:lvl7pPr>
             <a:lvl8pPr>
+              <a:buNone/>
               <a:defRPr sz="4350" b="1">
                 <a:solidFill>
                   <a:srgbClr val="087F8C"/>
@@ -11053,6 +11298,7 @@
               </a:defRPr>
             </a:lvl8pPr>
             <a:lvl9pPr>
+              <a:buNone/>
               <a:defRPr sz="4350" b="1">
                 <a:solidFill>
                   <a:srgbClr val="087F8C"/>
@@ -11065,6 +11311,7 @@
           </a:lstStyle>
           <a:p xmlns:a="http://schemas.openxmlformats.org/drawingml/2006/main">
             <a:pPr>
+              <a:buNone/>
               <a:defRPr sz="4350" b="1">
                 <a:solidFill>
                   <a:srgbClr val="087F8C"/>
@@ -11104,8 +11351,8 @@
         </p:nvSpPr>
         <p:spPr>
           <a:xfrm xmlns:a="http://schemas.openxmlformats.org/drawingml/2006/main">
-            <a:off x="1238250" y="28765500"/>
-            <a:ext cx="13239750" cy="1257300"/>
+            <a:off x="1238250" y="28670250"/>
+            <a:ext cx="13239750" cy="1571625"/>
           </a:xfrm>
           <a:prstGeom xmlns:a="http://schemas.openxmlformats.org/drawingml/2006/main" prst="rect">
             <a:avLst/>
@@ -11121,7 +11368,7 @@
           </a:bodyPr>
           <a:lstStyle xmlns:a="http://schemas.openxmlformats.org/drawingml/2006/main">
             <a:defPPr>
-              <a:defRPr sz="3000" b="0">
+              <a:defRPr sz="2775" b="0">
                 <a:solidFill>
                   <a:srgbClr val="132F43"/>
                 </a:solidFill>
@@ -11131,6 +11378,7 @@
               </a:defRPr>
             </a:defPPr>
             <a:lvl1pPr>
+              <a:buNone/>
               <a:defRPr sz="3000" b="0">
                 <a:solidFill>
                   <a:srgbClr val="132F43"/>
@@ -11141,6 +11389,7 @@
               </a:defRPr>
             </a:lvl1pPr>
             <a:lvl2pPr>
+              <a:buNone/>
               <a:defRPr sz="3000" b="0">
                 <a:solidFill>
                   <a:srgbClr val="132F43"/>
@@ -11151,6 +11400,7 @@
               </a:defRPr>
             </a:lvl2pPr>
             <a:lvl3pPr>
+              <a:buNone/>
               <a:defRPr sz="3000" b="0">
                 <a:solidFill>
                   <a:srgbClr val="132F43"/>
@@ -11161,6 +11411,7 @@
               </a:defRPr>
             </a:lvl3pPr>
             <a:lvl4pPr>
+              <a:buNone/>
               <a:defRPr sz="3000" b="0">
                 <a:solidFill>
                   <a:srgbClr val="132F43"/>
@@ -11171,6 +11422,7 @@
               </a:defRPr>
             </a:lvl4pPr>
             <a:lvl5pPr>
+              <a:buNone/>
               <a:defRPr sz="3000" b="0">
                 <a:solidFill>
                   <a:srgbClr val="132F43"/>
@@ -11181,6 +11433,7 @@
               </a:defRPr>
             </a:lvl5pPr>
             <a:lvl6pPr>
+              <a:buNone/>
               <a:defRPr sz="3000" b="0">
                 <a:solidFill>
                   <a:srgbClr val="132F43"/>
@@ -11191,6 +11444,7 @@
               </a:defRPr>
             </a:lvl6pPr>
             <a:lvl7pPr>
+              <a:buNone/>
               <a:defRPr sz="3000" b="0">
                 <a:solidFill>
                   <a:srgbClr val="132F43"/>
@@ -11201,6 +11455,7 @@
               </a:defRPr>
             </a:lvl7pPr>
             <a:lvl8pPr>
+              <a:buNone/>
               <a:defRPr sz="3000" b="0">
                 <a:solidFill>
                   <a:srgbClr val="132F43"/>
@@ -11211,6 +11466,7 @@
               </a:defRPr>
             </a:lvl8pPr>
             <a:lvl9pPr>
+              <a:buNone/>
               <a:defRPr sz="3000" b="0">
                 <a:solidFill>
                   <a:srgbClr val="132F43"/>
@@ -11223,7 +11479,8 @@
           </a:lstStyle>
           <a:p xmlns:a="http://schemas.openxmlformats.org/drawingml/2006/main">
             <a:pPr>
-              <a:defRPr sz="3000" b="0">
+              <a:buNone/>
+              <a:defRPr sz="2775" b="0">
                 <a:solidFill>
                   <a:srgbClr val="132F43"/>
                 </a:solidFill>
@@ -11233,7 +11490,7 @@
               </a:defRPr>
             </a:pPr>
             <a:r>
-              <a:rPr sz="3000" b="0">
+              <a:rPr sz="2775" b="0">
                 <a:solidFill>
                   <a:srgbClr val="132F43"/>
                 </a:solidFill>
@@ -11241,12 +11498,13 @@
                 <a:ea typeface="Malgun Gothic"/>
                 <a:cs typeface="Malgun Gothic"/>
               </a:rPr>
-              <a:t>네 NN의 평균 F1은 병합보다 높았다.</a:t>
+              <a:t>위 범위는 신경망 평균과 LR 단일 적합의 범위이다.</a:t>
             </a:r>
           </a:p>
           <a:p xmlns:a="http://schemas.openxmlformats.org/drawingml/2006/main">
             <a:pPr>
-              <a:defRPr sz="3000" b="0">
+              <a:buNone/>
+              <a:defRPr sz="2775" b="0">
                 <a:solidFill>
                   <a:srgbClr val="132F43"/>
                 </a:solidFill>
@@ -11256,7 +11514,7 @@
               </a:defRPr>
             </a:pPr>
             <a:r>
-              <a:rPr sz="3000" b="0">
+              <a:rPr sz="2775" b="0">
                 <a:solidFill>
                   <a:srgbClr val="132F43"/>
                 </a:solidFill>
@@ -11264,7 +11522,31 @@
                 <a:ea typeface="Malgun Gothic"/>
                 <a:cs typeface="Malgun Gothic"/>
               </a:rPr>
-              <a:t>동일 seed 12쌍 중 11쌍 증가; LSTM 2027은 −0.0011.</a:t>
+              <a:t>직접 학습은 같은 seed 12쌍 중 11쌍에서 F1 증가.</a:t>
+            </a:r>
+          </a:p>
+          <a:p xmlns:a="http://schemas.openxmlformats.org/drawingml/2006/main">
+            <a:pPr>
+              <a:buNone/>
+              <a:defRPr sz="2775" b="0">
+                <a:solidFill>
+                  <a:srgbClr val="132F43"/>
+                </a:solidFill>
+                <a:latin typeface="Malgun Gothic"/>
+                <a:ea typeface="Malgun Gothic"/>
+                <a:cs typeface="Malgun Gothic"/>
+              </a:defRPr>
+            </a:pPr>
+            <a:r>
+              <a:rPr sz="2775" b="0">
+                <a:solidFill>
+                  <a:srgbClr val="132F43"/>
+                </a:solidFill>
+                <a:latin typeface="Malgun Gothic"/>
+                <a:ea typeface="Malgun Gothic"/>
+                <a:cs typeface="Malgun Gothic"/>
+              </a:rPr>
+              <a:t>LSTM 2027은 −0.0011로 예외도 관찰됐다.</a:t>
             </a:r>
           </a:p>
         </p:txBody>
@@ -11302,7 +11584,7 @@
           </a:bodyPr>
           <a:lstStyle xmlns:a="http://schemas.openxmlformats.org/drawingml/2006/main">
             <a:defPPr>
-              <a:defRPr sz="3825" b="1">
+              <a:defRPr sz="3675" b="1">
                 <a:solidFill>
                   <a:srgbClr val="132F43"/>
                 </a:solidFill>
@@ -11312,6 +11594,7 @@
               </a:defRPr>
             </a:defPPr>
             <a:lvl1pPr>
+              <a:buNone/>
               <a:defRPr sz="3825" b="1">
                 <a:solidFill>
                   <a:srgbClr val="132F43"/>
@@ -11322,6 +11605,7 @@
               </a:defRPr>
             </a:lvl1pPr>
             <a:lvl2pPr>
+              <a:buNone/>
               <a:defRPr sz="3825" b="1">
                 <a:solidFill>
                   <a:srgbClr val="132F43"/>
@@ -11332,6 +11616,7 @@
               </a:defRPr>
             </a:lvl2pPr>
             <a:lvl3pPr>
+              <a:buNone/>
               <a:defRPr sz="3825" b="1">
                 <a:solidFill>
                   <a:srgbClr val="132F43"/>
@@ -11342,6 +11627,7 @@
               </a:defRPr>
             </a:lvl3pPr>
             <a:lvl4pPr>
+              <a:buNone/>
               <a:defRPr sz="3825" b="1">
                 <a:solidFill>
                   <a:srgbClr val="132F43"/>
@@ -11352,6 +11638,7 @@
               </a:defRPr>
             </a:lvl4pPr>
             <a:lvl5pPr>
+              <a:buNone/>
               <a:defRPr sz="3825" b="1">
                 <a:solidFill>
                   <a:srgbClr val="132F43"/>
@@ -11362,6 +11649,7 @@
               </a:defRPr>
             </a:lvl5pPr>
             <a:lvl6pPr>
+              <a:buNone/>
               <a:defRPr sz="3825" b="1">
                 <a:solidFill>
                   <a:srgbClr val="132F43"/>
@@ -11372,6 +11660,7 @@
               </a:defRPr>
             </a:lvl6pPr>
             <a:lvl7pPr>
+              <a:buNone/>
               <a:defRPr sz="3825" b="1">
                 <a:solidFill>
                   <a:srgbClr val="132F43"/>
@@ -11382,6 +11671,7 @@
               </a:defRPr>
             </a:lvl7pPr>
             <a:lvl8pPr>
+              <a:buNone/>
               <a:defRPr sz="3825" b="1">
                 <a:solidFill>
                   <a:srgbClr val="132F43"/>
@@ -11392,6 +11682,7 @@
               </a:defRPr>
             </a:lvl8pPr>
             <a:lvl9pPr>
+              <a:buNone/>
               <a:defRPr sz="3825" b="1">
                 <a:solidFill>
                   <a:srgbClr val="132F43"/>
@@ -11404,7 +11695,8 @@
           </a:lstStyle>
           <a:p xmlns:a="http://schemas.openxmlformats.org/drawingml/2006/main">
             <a:pPr>
-              <a:defRPr sz="3825" b="1">
+              <a:buNone/>
+              <a:defRPr sz="3675" b="1">
                 <a:solidFill>
                   <a:srgbClr val="132F43"/>
                 </a:solidFill>
@@ -11414,7 +11706,7 @@
               </a:defRPr>
             </a:pPr>
             <a:r>
-              <a:rPr sz="3825" b="1">
+              <a:rPr sz="3675" b="1">
                 <a:solidFill>
                   <a:srgbClr val="132F43"/>
                 </a:solidFill>
@@ -11422,7 +11714,7 @@
                 <a:ea typeface="Malgun Gothic"/>
                 <a:cs typeface="Malgun Gothic"/>
               </a:rPr>
-              <a:t>준비된 1구간의 CPU 처리 시간</a:t>
+              <a:t>3상태 직접 학습 · PC 처리 시간</a:t>
             </a:r>
           </a:p>
         </p:txBody>
@@ -11432,7 +11724,7 @@
           <p:cNvPr id="22" name="Chart">
             <a:extLst xmlns:a="http://schemas.openxmlformats.org/drawingml/2006/main">
               <a:ext uri="{FF2B5EF4-FFF2-40B4-BE49-F238E27FC236}">
-                <a16:creationId xmlns:a16="http://schemas.microsoft.com/office/drawing/2014/main" id="{BD075742-F9DE-46CF-B620-376707B6B7C7}"/>
+                <a16:creationId xmlns:a16="http://schemas.microsoft.com/office/drawing/2014/main" id="{2A0AA04E-FEBA-42E9-B6B7-FD800B0C2A0E}"/>
               </a:ext>
             </a:extLst>
           </p:cNvPr>
@@ -11440,12 +11732,12 @@
           <p:nvPr/>
         </p:nvGraphicFramePr>
         <p:xfrm>
-          <a:off xmlns:a="http://schemas.openxmlformats.org/drawingml/2006/main" x="15621000" y="20955000"/>
-          <a:ext xmlns:a="http://schemas.openxmlformats.org/drawingml/2006/main" cx="13416750" cy="4953000"/>
+          <a:off xmlns:a="http://schemas.openxmlformats.org/drawingml/2006/main" x="15621000" y="21240750"/>
+          <a:ext xmlns:a="http://schemas.openxmlformats.org/drawingml/2006/main" cx="13416725" cy="4667250"/>
         </p:xfrm>
         <a:graphic xmlns:a="http://schemas.openxmlformats.org/drawingml/2006/main">
           <a:graphicData uri="http://schemas.openxmlformats.org/drawingml/2006/chart">
-            <c:chart xmlns:r="http://schemas.openxmlformats.org/officeDocument/2006/relationships" xmlns:c="http://schemas.openxmlformats.org/drawingml/2006/chart" r:id="R0f229560d17d45a6"/>
+            <c:chart xmlns:r="http://schemas.openxmlformats.org/officeDocument/2006/relationships" xmlns:c="http://schemas.openxmlformats.org/drawingml/2006/chart" r:id="R4a0958043e7f4415"/>
           </a:graphicData>
         </a:graphic>
       </p:graphicFrame>
@@ -11482,7 +11774,7 @@
           </a:bodyPr>
           <a:lstStyle xmlns:a="http://schemas.openxmlformats.org/drawingml/2006/main">
             <a:defPPr>
-              <a:defRPr sz="3525" b="1">
+              <a:defRPr sz="3300" b="1">
                 <a:solidFill>
                   <a:srgbClr val="132F43"/>
                 </a:solidFill>
@@ -11492,6 +11784,7 @@
               </a:defRPr>
             </a:defPPr>
             <a:lvl1pPr>
+              <a:buNone/>
               <a:defRPr sz="3525" b="1">
                 <a:solidFill>
                   <a:srgbClr val="132F43"/>
@@ -11502,6 +11795,7 @@
               </a:defRPr>
             </a:lvl1pPr>
             <a:lvl2pPr>
+              <a:buNone/>
               <a:defRPr sz="3525" b="1">
                 <a:solidFill>
                   <a:srgbClr val="132F43"/>
@@ -11512,6 +11806,7 @@
               </a:defRPr>
             </a:lvl2pPr>
             <a:lvl3pPr>
+              <a:buNone/>
               <a:defRPr sz="3525" b="1">
                 <a:solidFill>
                   <a:srgbClr val="132F43"/>
@@ -11522,6 +11817,7 @@
               </a:defRPr>
             </a:lvl3pPr>
             <a:lvl4pPr>
+              <a:buNone/>
               <a:defRPr sz="3525" b="1">
                 <a:solidFill>
                   <a:srgbClr val="132F43"/>
@@ -11532,6 +11828,7 @@
               </a:defRPr>
             </a:lvl4pPr>
             <a:lvl5pPr>
+              <a:buNone/>
               <a:defRPr sz="3525" b="1">
                 <a:solidFill>
                   <a:srgbClr val="132F43"/>
@@ -11542,6 +11839,7 @@
               </a:defRPr>
             </a:lvl5pPr>
             <a:lvl6pPr>
+              <a:buNone/>
               <a:defRPr sz="3525" b="1">
                 <a:solidFill>
                   <a:srgbClr val="132F43"/>
@@ -11552,6 +11850,7 @@
               </a:defRPr>
             </a:lvl6pPr>
             <a:lvl7pPr>
+              <a:buNone/>
               <a:defRPr sz="3525" b="1">
                 <a:solidFill>
                   <a:srgbClr val="132F43"/>
@@ -11562,6 +11861,7 @@
               </a:defRPr>
             </a:lvl7pPr>
             <a:lvl8pPr>
+              <a:buNone/>
               <a:defRPr sz="3525" b="1">
                 <a:solidFill>
                   <a:srgbClr val="132F43"/>
@@ -11572,6 +11872,7 @@
               </a:defRPr>
             </a:lvl8pPr>
             <a:lvl9pPr>
+              <a:buNone/>
               <a:defRPr sz="3525" b="1">
                 <a:solidFill>
                   <a:srgbClr val="132F43"/>
@@ -11584,7 +11885,8 @@
           </a:lstStyle>
           <a:p xmlns:a="http://schemas.openxmlformats.org/drawingml/2006/main">
             <a:pPr>
-              <a:defRPr sz="3525" b="1">
+              <a:buNone/>
+              <a:defRPr sz="3300" b="1">
                 <a:solidFill>
                   <a:srgbClr val="132F43"/>
                 </a:solidFill>
@@ -11594,7 +11896,7 @@
               </a:defRPr>
             </a:pPr>
             <a:r>
-              <a:rPr sz="3525" b="1">
+              <a:rPr sz="3300" b="1">
                 <a:solidFill>
                   <a:srgbClr val="132F43"/>
                 </a:solidFill>
@@ -11602,7 +11904,7 @@
                 <a:ea typeface="Malgun Gothic"/>
                 <a:cs typeface="Malgun Gothic"/>
               </a:rPr>
-              <a:t>동일 18개 특징: LR3와 FMLP3</a:t>
+              <a:t>동일 18특징: FMLP3 / LR3 처리 시간</a:t>
             </a:r>
           </a:p>
         </p:txBody>
@@ -11640,7 +11942,7 @@
           </a:bodyPr>
           <a:lstStyle xmlns:a="http://schemas.openxmlformats.org/drawingml/2006/main">
             <a:defPPr>
-              <a:defRPr sz="5250" b="1">
+              <a:defRPr sz="4575" b="1">
                 <a:solidFill>
                   <a:srgbClr val="087F8C"/>
                 </a:solidFill>
@@ -11650,6 +11952,7 @@
               </a:defRPr>
             </a:defPPr>
             <a:lvl1pPr>
+              <a:buNone/>
               <a:defRPr sz="5250" b="1">
                 <a:solidFill>
                   <a:srgbClr val="087F8C"/>
@@ -11660,6 +11963,7 @@
               </a:defRPr>
             </a:lvl1pPr>
             <a:lvl2pPr>
+              <a:buNone/>
               <a:defRPr sz="5250" b="1">
                 <a:solidFill>
                   <a:srgbClr val="087F8C"/>
@@ -11670,6 +11974,7 @@
               </a:defRPr>
             </a:lvl2pPr>
             <a:lvl3pPr>
+              <a:buNone/>
               <a:defRPr sz="5250" b="1">
                 <a:solidFill>
                   <a:srgbClr val="087F8C"/>
@@ -11680,6 +11985,7 @@
               </a:defRPr>
             </a:lvl3pPr>
             <a:lvl4pPr>
+              <a:buNone/>
               <a:defRPr sz="5250" b="1">
                 <a:solidFill>
                   <a:srgbClr val="087F8C"/>
@@ -11690,6 +11996,7 @@
               </a:defRPr>
             </a:lvl4pPr>
             <a:lvl5pPr>
+              <a:buNone/>
               <a:defRPr sz="5250" b="1">
                 <a:solidFill>
                   <a:srgbClr val="087F8C"/>
@@ -11700,6 +12007,7 @@
               </a:defRPr>
             </a:lvl5pPr>
             <a:lvl6pPr>
+              <a:buNone/>
               <a:defRPr sz="5250" b="1">
                 <a:solidFill>
                   <a:srgbClr val="087F8C"/>
@@ -11710,6 +12018,7 @@
               </a:defRPr>
             </a:lvl6pPr>
             <a:lvl7pPr>
+              <a:buNone/>
               <a:defRPr sz="5250" b="1">
                 <a:solidFill>
                   <a:srgbClr val="087F8C"/>
@@ -11720,6 +12029,7 @@
               </a:defRPr>
             </a:lvl7pPr>
             <a:lvl8pPr>
+              <a:buNone/>
               <a:defRPr sz="5250" b="1">
                 <a:solidFill>
                   <a:srgbClr val="087F8C"/>
@@ -11730,6 +12040,7 @@
               </a:defRPr>
             </a:lvl8pPr>
             <a:lvl9pPr>
+              <a:buNone/>
               <a:defRPr sz="5250" b="1">
                 <a:solidFill>
                   <a:srgbClr val="087F8C"/>
@@ -11742,7 +12053,8 @@
           </a:lstStyle>
           <a:p xmlns:a="http://schemas.openxmlformats.org/drawingml/2006/main">
             <a:pPr>
-              <a:defRPr sz="5250" b="1">
+              <a:buNone/>
+              <a:defRPr sz="4575" b="1">
                 <a:solidFill>
                   <a:srgbClr val="087F8C"/>
                 </a:solidFill>
@@ -11752,7 +12064,7 @@
               </a:defRPr>
             </a:pPr>
             <a:r>
-              <a:rPr sz="5250" b="1">
+              <a:rPr sz="4575" b="1">
                 <a:solidFill>
                   <a:srgbClr val="087F8C"/>
                 </a:solidFill>
@@ -11760,7 +12072,7 @@
                 <a:ea typeface="Malgun Gothic"/>
                 <a:cs typeface="Malgun Gothic"/>
               </a:rPr>
-              <a:t>처리 시간 약 14.2배 차이</a:t>
+              <a:t>PC 처리 시간 약 14.2배 차이</a:t>
             </a:r>
           </a:p>
         </p:txBody>
@@ -11782,7 +12094,7 @@
         <p:spPr>
           <a:xfrm xmlns:a="http://schemas.openxmlformats.org/drawingml/2006/main">
             <a:off x="15716250" y="28194000"/>
-            <a:ext cx="13321500" cy="1314450"/>
+            <a:ext cx="13321475" cy="1190625"/>
           </a:xfrm>
           <a:prstGeom xmlns:a="http://schemas.openxmlformats.org/drawingml/2006/main" prst="rect">
             <a:avLst/>
@@ -11798,7 +12110,7 @@
           </a:bodyPr>
           <a:lstStyle xmlns:a="http://schemas.openxmlformats.org/drawingml/2006/main">
             <a:defPPr>
-              <a:defRPr sz="3450" b="0">
+              <a:defRPr sz="2850" b="0">
                 <a:solidFill>
                   <a:srgbClr val="132F43"/>
                 </a:solidFill>
@@ -11808,6 +12120,7 @@
               </a:defRPr>
             </a:defPPr>
             <a:lvl1pPr>
+              <a:buNone/>
               <a:defRPr sz="3450" b="0">
                 <a:solidFill>
                   <a:srgbClr val="132F43"/>
@@ -11818,6 +12131,7 @@
               </a:defRPr>
             </a:lvl1pPr>
             <a:lvl2pPr>
+              <a:buNone/>
               <a:defRPr sz="3450" b="0">
                 <a:solidFill>
                   <a:srgbClr val="132F43"/>
@@ -11828,6 +12142,7 @@
               </a:defRPr>
             </a:lvl2pPr>
             <a:lvl3pPr>
+              <a:buNone/>
               <a:defRPr sz="3450" b="0">
                 <a:solidFill>
                   <a:srgbClr val="132F43"/>
@@ -11838,6 +12153,7 @@
               </a:defRPr>
             </a:lvl3pPr>
             <a:lvl4pPr>
+              <a:buNone/>
               <a:defRPr sz="3450" b="0">
                 <a:solidFill>
                   <a:srgbClr val="132F43"/>
@@ -11848,6 +12164,7 @@
               </a:defRPr>
             </a:lvl4pPr>
             <a:lvl5pPr>
+              <a:buNone/>
               <a:defRPr sz="3450" b="0">
                 <a:solidFill>
                   <a:srgbClr val="132F43"/>
@@ -11858,6 +12175,7 @@
               </a:defRPr>
             </a:lvl5pPr>
             <a:lvl6pPr>
+              <a:buNone/>
               <a:defRPr sz="3450" b="0">
                 <a:solidFill>
                   <a:srgbClr val="132F43"/>
@@ -11868,6 +12186,7 @@
               </a:defRPr>
             </a:lvl6pPr>
             <a:lvl7pPr>
+              <a:buNone/>
               <a:defRPr sz="3450" b="0">
                 <a:solidFill>
                   <a:srgbClr val="132F43"/>
@@ -11878,6 +12197,7 @@
               </a:defRPr>
             </a:lvl7pPr>
             <a:lvl8pPr>
+              <a:buNone/>
               <a:defRPr sz="3450" b="0">
                 <a:solidFill>
                   <a:srgbClr val="132F43"/>
@@ -11888,6 +12208,7 @@
               </a:defRPr>
             </a:lvl8pPr>
             <a:lvl9pPr>
+              <a:buNone/>
               <a:defRPr sz="3450" b="0">
                 <a:solidFill>
                   <a:srgbClr val="132F43"/>
@@ -11900,7 +12221,8 @@
           </a:lstStyle>
           <a:p xmlns:a="http://schemas.openxmlformats.org/drawingml/2006/main">
             <a:pPr>
-              <a:defRPr sz="3450" b="0">
+              <a:buNone/>
+              <a:defRPr sz="2850" b="0">
                 <a:solidFill>
                   <a:srgbClr val="132F43"/>
                 </a:solidFill>
@@ -11910,7 +12232,7 @@
               </a:defRPr>
             </a:pPr>
             <a:r>
-              <a:rPr sz="3450" b="0">
+              <a:rPr sz="2850" b="0">
                 <a:solidFill>
                   <a:srgbClr val="132F43"/>
                 </a:solidFill>
@@ -11918,12 +12240,13 @@
                 <a:ea typeface="Malgun Gothic"/>
                 <a:cs typeface="Malgun Gothic"/>
               </a:rPr>
-              <a:t>LR3  0.073ms · 57개 파라미터</a:t>
+              <a:t>LR3  F1 0.9994 · 0.073ms · 57개 파라미터</a:t>
             </a:r>
           </a:p>
           <a:p xmlns:a="http://schemas.openxmlformats.org/drawingml/2006/main">
             <a:pPr>
-              <a:defRPr sz="3450" b="0">
+              <a:buNone/>
+              <a:defRPr sz="2850" b="0">
                 <a:solidFill>
                   <a:srgbClr val="132F43"/>
                 </a:solidFill>
@@ -11933,7 +12256,7 @@
               </a:defRPr>
             </a:pPr>
             <a:r>
-              <a:rPr sz="3450" b="0">
+              <a:rPr sz="2850" b="0">
                 <a:solidFill>
                   <a:srgbClr val="132F43"/>
                 </a:solidFill>
@@ -11941,7 +12264,7 @@
                 <a:ea typeface="Malgun Gothic"/>
                 <a:cs typeface="Malgun Gothic"/>
               </a:rPr>
-              <a:t>FMLP3  1.043ms · 10,883개 파라미터</a:t>
+              <a:t>FMLP3  F1 0.9986 · 1.043ms · 10,883개 파라미터</a:t>
             </a:r>
           </a:p>
         </p:txBody>
@@ -11963,7 +12286,7 @@
         <p:spPr>
           <a:xfrm xmlns:a="http://schemas.openxmlformats.org/drawingml/2006/main">
             <a:off x="15716250" y="29718000"/>
-            <a:ext cx="13321500" cy="1047750"/>
+            <a:ext cx="13321475" cy="1238250"/>
           </a:xfrm>
           <a:prstGeom xmlns:a="http://schemas.openxmlformats.org/drawingml/2006/main" prst="rect">
             <a:avLst/>
@@ -11979,7 +12302,7 @@
           </a:bodyPr>
           <a:lstStyle xmlns:a="http://schemas.openxmlformats.org/drawingml/2006/main">
             <a:defPPr>
-              <a:defRPr sz="2775" b="0">
+              <a:defRPr sz="2400" b="0">
                 <a:solidFill>
                   <a:srgbClr val="4C606E"/>
                 </a:solidFill>
@@ -11989,6 +12312,7 @@
               </a:defRPr>
             </a:defPPr>
             <a:lvl1pPr>
+              <a:buNone/>
               <a:defRPr sz="2775" b="0">
                 <a:solidFill>
                   <a:srgbClr val="4C606E"/>
@@ -11999,6 +12323,7 @@
               </a:defRPr>
             </a:lvl1pPr>
             <a:lvl2pPr>
+              <a:buNone/>
               <a:defRPr sz="2775" b="0">
                 <a:solidFill>
                   <a:srgbClr val="4C606E"/>
@@ -12009,6 +12334,7 @@
               </a:defRPr>
             </a:lvl2pPr>
             <a:lvl3pPr>
+              <a:buNone/>
               <a:defRPr sz="2775" b="0">
                 <a:solidFill>
                   <a:srgbClr val="4C606E"/>
@@ -12019,6 +12345,7 @@
               </a:defRPr>
             </a:lvl3pPr>
             <a:lvl4pPr>
+              <a:buNone/>
               <a:defRPr sz="2775" b="0">
                 <a:solidFill>
                   <a:srgbClr val="4C606E"/>
@@ -12029,6 +12356,7 @@
               </a:defRPr>
             </a:lvl4pPr>
             <a:lvl5pPr>
+              <a:buNone/>
               <a:defRPr sz="2775" b="0">
                 <a:solidFill>
                   <a:srgbClr val="4C606E"/>
@@ -12039,6 +12367,7 @@
               </a:defRPr>
             </a:lvl5pPr>
             <a:lvl6pPr>
+              <a:buNone/>
               <a:defRPr sz="2775" b="0">
                 <a:solidFill>
                   <a:srgbClr val="4C606E"/>
@@ -12049,6 +12378,7 @@
               </a:defRPr>
             </a:lvl6pPr>
             <a:lvl7pPr>
+              <a:buNone/>
               <a:defRPr sz="2775" b="0">
                 <a:solidFill>
                   <a:srgbClr val="4C606E"/>
@@ -12059,6 +12389,7 @@
               </a:defRPr>
             </a:lvl7pPr>
             <a:lvl8pPr>
+              <a:buNone/>
               <a:defRPr sz="2775" b="0">
                 <a:solidFill>
                   <a:srgbClr val="4C606E"/>
@@ -12069,6 +12400,7 @@
               </a:defRPr>
             </a:lvl8pPr>
             <a:lvl9pPr>
+              <a:buNone/>
               <a:defRPr sz="2775" b="0">
                 <a:solidFill>
                   <a:srgbClr val="4C606E"/>
@@ -12081,7 +12413,8 @@
           </a:lstStyle>
           <a:p xmlns:a="http://schemas.openxmlformats.org/drawingml/2006/main">
             <a:pPr>
-              <a:defRPr sz="2775" b="0">
+              <a:buNone/>
+              <a:defRPr sz="2400" b="0">
                 <a:solidFill>
                   <a:srgbClr val="4C606E"/>
                 </a:solidFill>
@@ -12091,7 +12424,7 @@
               </a:defRPr>
             </a:pPr>
             <a:r>
-              <a:rPr sz="2775" b="0">
+              <a:rPr sz="2400" b="0">
                 <a:solidFill>
                   <a:srgbClr val="4C606E"/>
                 </a:solidFill>
@@ -12099,7 +12432,55 @@
                 <a:ea typeface="Malgun Gothic"/>
                 <a:cs typeface="Malgun Gothic"/>
               </a:rPr>
-              <a:t>작은 F1 차이를 모델 우월성이나 성능 동등성으로 해석하지 않는다.</a:t>
+              <a:t>고정 PC·구현의 비용으로, 스마트폰 실측과 구분한다.</a:t>
+            </a:r>
+          </a:p>
+          <a:p xmlns:a="http://schemas.openxmlformats.org/drawingml/2006/main">
+            <a:pPr>
+              <a:buNone/>
+              <a:defRPr sz="2400" b="0">
+                <a:solidFill>
+                  <a:srgbClr val="4C606E"/>
+                </a:solidFill>
+                <a:latin typeface="Malgun Gothic"/>
+                <a:ea typeface="Malgun Gothic"/>
+                <a:cs typeface="Malgun Gothic"/>
+              </a:defRPr>
+            </a:pPr>
+            <a:r>
+              <a:rPr sz="2400" b="0">
+                <a:solidFill>
+                  <a:srgbClr val="4C606E"/>
+                </a:solidFill>
+                <a:latin typeface="Malgun Gothic"/>
+                <a:ea typeface="Malgun Gothic"/>
+                <a:cs typeface="Malgun Gothic"/>
+              </a:rPr>
+              <a:t>작은 F1 차이로 우월성·동등성을 판단하지 않는다.</a:t>
+            </a:r>
+          </a:p>
+          <a:p xmlns:a="http://schemas.openxmlformats.org/drawingml/2006/main">
+            <a:pPr>
+              <a:buNone/>
+              <a:defRPr sz="2400" b="0">
+                <a:solidFill>
+                  <a:srgbClr val="4C606E"/>
+                </a:solidFill>
+                <a:latin typeface="Malgun Gothic"/>
+                <a:ea typeface="Malgun Gothic"/>
+                <a:cs typeface="Malgun Gothic"/>
+              </a:defRPr>
+            </a:pPr>
+            <a:r>
+              <a:rPr sz="2400" b="0">
+                <a:solidFill>
+                  <a:srgbClr val="4C606E"/>
+                </a:solidFill>
+                <a:latin typeface="Malgun Gothic"/>
+                <a:ea typeface="Malgun Gothic"/>
+                <a:cs typeface="Malgun Gothic"/>
+              </a:rPr>
+              <a:t>14.2배는 반올림 전 원자료로 계산했다.</a:t>
             </a:r>
           </a:p>
         </p:txBody>
@@ -12137,7 +12518,7 @@
           </a:bodyPr>
           <a:lstStyle xmlns:a="http://schemas.openxmlformats.org/drawingml/2006/main">
             <a:defPPr>
-              <a:defRPr sz="4650" b="1">
+              <a:defRPr sz="4425" b="1">
                 <a:solidFill>
                   <a:srgbClr val="087F8C"/>
                 </a:solidFill>
@@ -12147,6 +12528,7 @@
               </a:defRPr>
             </a:defPPr>
             <a:lvl1pPr>
+              <a:buNone/>
               <a:defRPr sz="4650" b="1">
                 <a:solidFill>
                   <a:srgbClr val="087F8C"/>
@@ -12157,6 +12539,7 @@
               </a:defRPr>
             </a:lvl1pPr>
             <a:lvl2pPr>
+              <a:buNone/>
               <a:defRPr sz="4650" b="1">
                 <a:solidFill>
                   <a:srgbClr val="087F8C"/>
@@ -12167,6 +12550,7 @@
               </a:defRPr>
             </a:lvl2pPr>
             <a:lvl3pPr>
+              <a:buNone/>
               <a:defRPr sz="4650" b="1">
                 <a:solidFill>
                   <a:srgbClr val="087F8C"/>
@@ -12177,6 +12561,7 @@
               </a:defRPr>
             </a:lvl3pPr>
             <a:lvl4pPr>
+              <a:buNone/>
               <a:defRPr sz="4650" b="1">
                 <a:solidFill>
                   <a:srgbClr val="087F8C"/>
@@ -12187,6 +12572,7 @@
               </a:defRPr>
             </a:lvl4pPr>
             <a:lvl5pPr>
+              <a:buNone/>
               <a:defRPr sz="4650" b="1">
                 <a:solidFill>
                   <a:srgbClr val="087F8C"/>
@@ -12197,6 +12583,7 @@
               </a:defRPr>
             </a:lvl5pPr>
             <a:lvl6pPr>
+              <a:buNone/>
               <a:defRPr sz="4650" b="1">
                 <a:solidFill>
                   <a:srgbClr val="087F8C"/>
@@ -12207,6 +12594,7 @@
               </a:defRPr>
             </a:lvl6pPr>
             <a:lvl7pPr>
+              <a:buNone/>
               <a:defRPr sz="4650" b="1">
                 <a:solidFill>
                   <a:srgbClr val="087F8C"/>
@@ -12217,6 +12605,7 @@
               </a:defRPr>
             </a:lvl7pPr>
             <a:lvl8pPr>
+              <a:buNone/>
               <a:defRPr sz="4650" b="1">
                 <a:solidFill>
                   <a:srgbClr val="087F8C"/>
@@ -12227,6 +12616,7 @@
               </a:defRPr>
             </a:lvl8pPr>
             <a:lvl9pPr>
+              <a:buNone/>
               <a:defRPr sz="4650" b="1">
                 <a:solidFill>
                   <a:srgbClr val="087F8C"/>
@@ -12239,7 +12629,8 @@
           </a:lstStyle>
           <a:p xmlns:a="http://schemas.openxmlformats.org/drawingml/2006/main">
             <a:pPr>
-              <a:defRPr sz="4650" b="1">
+              <a:buNone/>
+              <a:defRPr sz="4425" b="1">
                 <a:solidFill>
                   <a:srgbClr val="087F8C"/>
                 </a:solidFill>
@@ -12249,7 +12640,7 @@
               </a:defRPr>
             </a:pPr>
             <a:r>
-              <a:rPr sz="4650" b="1">
+              <a:rPr sz="4425" b="1">
                 <a:solidFill>
                   <a:srgbClr val="087F8C"/>
                 </a:solidFill>
@@ -12257,7 +12648,7 @@
                 <a:ea typeface="Malgun Gothic"/>
                 <a:cs typeface="Malgun Gothic"/>
               </a:rPr>
-              <a:t>04  센서 구간을 활동 요약으로</a:t>
+              <a:t>04  실제 입력과 예측·오류</a:t>
             </a:r>
           </a:p>
         </p:txBody>
@@ -12267,7 +12658,7 @@
           <p:cNvPr id="28" name="Chart">
             <a:extLst xmlns:a="http://schemas.openxmlformats.org/drawingml/2006/main">
               <a:ext uri="{FF2B5EF4-FFF2-40B4-BE49-F238E27FC236}">
-                <a16:creationId xmlns:a16="http://schemas.microsoft.com/office/drawing/2014/main" id="{3FAA2184-AF7B-49C5-9E8D-9B3A8FC06DD3}"/>
+                <a16:creationId xmlns:a16="http://schemas.microsoft.com/office/drawing/2014/main" id="{37F40E43-87CF-49AA-9D6E-FD18F4532E22}"/>
               </a:ext>
             </a:extLst>
           </p:cNvPr>
@@ -12280,7 +12671,7 @@
         </p:xfrm>
         <a:graphic xmlns:a="http://schemas.openxmlformats.org/drawingml/2006/main">
           <a:graphicData uri="http://schemas.openxmlformats.org/drawingml/2006/chart">
-            <c:chart xmlns:r="http://schemas.openxmlformats.org/officeDocument/2006/relationships" xmlns:c="http://schemas.openxmlformats.org/drawingml/2006/chart" r:id="Rf82b62ccaba0467d"/>
+            <c:chart xmlns:r="http://schemas.openxmlformats.org/officeDocument/2006/relationships" xmlns:c="http://schemas.openxmlformats.org/drawingml/2006/chart" r:id="Re3796f8443b745bc"/>
           </a:graphicData>
         </a:graphic>
       </p:graphicFrame>
@@ -12327,6 +12718,7 @@
               </a:defRPr>
             </a:defPPr>
             <a:lvl1pPr>
+              <a:buNone/>
               <a:defRPr sz="3300" b="1">
                 <a:solidFill>
                   <a:srgbClr val="4C606E"/>
@@ -12337,6 +12729,7 @@
               </a:defRPr>
             </a:lvl1pPr>
             <a:lvl2pPr>
+              <a:buNone/>
               <a:defRPr sz="3300" b="1">
                 <a:solidFill>
                   <a:srgbClr val="4C606E"/>
@@ -12347,6 +12740,7 @@
               </a:defRPr>
             </a:lvl2pPr>
             <a:lvl3pPr>
+              <a:buNone/>
               <a:defRPr sz="3300" b="1">
                 <a:solidFill>
                   <a:srgbClr val="4C606E"/>
@@ -12357,6 +12751,7 @@
               </a:defRPr>
             </a:lvl3pPr>
             <a:lvl4pPr>
+              <a:buNone/>
               <a:defRPr sz="3300" b="1">
                 <a:solidFill>
                   <a:srgbClr val="4C606E"/>
@@ -12367,6 +12762,7 @@
               </a:defRPr>
             </a:lvl4pPr>
             <a:lvl5pPr>
+              <a:buNone/>
               <a:defRPr sz="3300" b="1">
                 <a:solidFill>
                   <a:srgbClr val="4C606E"/>
@@ -12377,6 +12773,7 @@
               </a:defRPr>
             </a:lvl5pPr>
             <a:lvl6pPr>
+              <a:buNone/>
               <a:defRPr sz="3300" b="1">
                 <a:solidFill>
                   <a:srgbClr val="4C606E"/>
@@ -12387,6 +12784,7 @@
               </a:defRPr>
             </a:lvl6pPr>
             <a:lvl7pPr>
+              <a:buNone/>
               <a:defRPr sz="3300" b="1">
                 <a:solidFill>
                   <a:srgbClr val="4C606E"/>
@@ -12397,6 +12795,7 @@
               </a:defRPr>
             </a:lvl7pPr>
             <a:lvl8pPr>
+              <a:buNone/>
               <a:defRPr sz="3300" b="1">
                 <a:solidFill>
                   <a:srgbClr val="4C606E"/>
@@ -12407,6 +12806,7 @@
               </a:defRPr>
             </a:lvl8pPr>
             <a:lvl9pPr>
+              <a:buNone/>
               <a:defRPr sz="3300" b="1">
                 <a:solidFill>
                   <a:srgbClr val="4C606E"/>
@@ -12419,6 +12819,7 @@
           </a:lstStyle>
           <a:p xmlns:a="http://schemas.openxmlformats.org/drawingml/2006/main">
             <a:pPr>
+              <a:buNone/>
               <a:defRPr sz="3300" b="1">
                 <a:solidFill>
                   <a:srgbClr val="4C606E"/>
@@ -12485,6 +12886,7 @@
               </a:defRPr>
             </a:defPPr>
             <a:lvl1pPr>
+              <a:buNone/>
               <a:defRPr sz="6150" b="1">
                 <a:solidFill>
                   <a:srgbClr val="087F8C"/>
@@ -12495,6 +12897,7 @@
               </a:defRPr>
             </a:lvl1pPr>
             <a:lvl2pPr>
+              <a:buNone/>
               <a:defRPr sz="6150" b="1">
                 <a:solidFill>
                   <a:srgbClr val="087F8C"/>
@@ -12505,6 +12908,7 @@
               </a:defRPr>
             </a:lvl2pPr>
             <a:lvl3pPr>
+              <a:buNone/>
               <a:defRPr sz="6150" b="1">
                 <a:solidFill>
                   <a:srgbClr val="087F8C"/>
@@ -12515,6 +12919,7 @@
               </a:defRPr>
             </a:lvl3pPr>
             <a:lvl4pPr>
+              <a:buNone/>
               <a:defRPr sz="6150" b="1">
                 <a:solidFill>
                   <a:srgbClr val="087F8C"/>
@@ -12525,6 +12930,7 @@
               </a:defRPr>
             </a:lvl4pPr>
             <a:lvl5pPr>
+              <a:buNone/>
               <a:defRPr sz="6150" b="1">
                 <a:solidFill>
                   <a:srgbClr val="087F8C"/>
@@ -12535,6 +12941,7 @@
               </a:defRPr>
             </a:lvl5pPr>
             <a:lvl6pPr>
+              <a:buNone/>
               <a:defRPr sz="6150" b="1">
                 <a:solidFill>
                   <a:srgbClr val="087F8C"/>
@@ -12545,6 +12952,7 @@
               </a:defRPr>
             </a:lvl6pPr>
             <a:lvl7pPr>
+              <a:buNone/>
               <a:defRPr sz="6150" b="1">
                 <a:solidFill>
                   <a:srgbClr val="087F8C"/>
@@ -12555,6 +12963,7 @@
               </a:defRPr>
             </a:lvl7pPr>
             <a:lvl8pPr>
+              <a:buNone/>
               <a:defRPr sz="6150" b="1">
                 <a:solidFill>
                   <a:srgbClr val="087F8C"/>
@@ -12565,6 +12974,7 @@
               </a:defRPr>
             </a:lvl8pPr>
             <a:lvl9pPr>
+              <a:buNone/>
               <a:defRPr sz="6150" b="1">
                 <a:solidFill>
                   <a:srgbClr val="087F8C"/>
@@ -12577,6 +12987,7 @@
           </a:lstStyle>
           <a:p xmlns:a="http://schemas.openxmlformats.org/drawingml/2006/main">
             <a:pPr>
+              <a:buNone/>
               <a:defRPr sz="6150" b="1">
                 <a:solidFill>
                   <a:srgbClr val="087F8C"/>
@@ -12643,6 +13054,7 @@
               </a:defRPr>
             </a:defPPr>
             <a:lvl1pPr>
+              <a:buNone/>
               <a:defRPr sz="3075" b="0">
                 <a:solidFill>
                   <a:srgbClr val="132F43"/>
@@ -12653,6 +13065,7 @@
               </a:defRPr>
             </a:lvl1pPr>
             <a:lvl2pPr>
+              <a:buNone/>
               <a:defRPr sz="3075" b="0">
                 <a:solidFill>
                   <a:srgbClr val="132F43"/>
@@ -12663,6 +13076,7 @@
               </a:defRPr>
             </a:lvl2pPr>
             <a:lvl3pPr>
+              <a:buNone/>
               <a:defRPr sz="3075" b="0">
                 <a:solidFill>
                   <a:srgbClr val="132F43"/>
@@ -12673,6 +13087,7 @@
               </a:defRPr>
             </a:lvl3pPr>
             <a:lvl4pPr>
+              <a:buNone/>
               <a:defRPr sz="3075" b="0">
                 <a:solidFill>
                   <a:srgbClr val="132F43"/>
@@ -12683,6 +13098,7 @@
               </a:defRPr>
             </a:lvl4pPr>
             <a:lvl5pPr>
+              <a:buNone/>
               <a:defRPr sz="3075" b="0">
                 <a:solidFill>
                   <a:srgbClr val="132F43"/>
@@ -12693,6 +13109,7 @@
               </a:defRPr>
             </a:lvl5pPr>
             <a:lvl6pPr>
+              <a:buNone/>
               <a:defRPr sz="3075" b="0">
                 <a:solidFill>
                   <a:srgbClr val="132F43"/>
@@ -12703,6 +13120,7 @@
               </a:defRPr>
             </a:lvl6pPr>
             <a:lvl7pPr>
+              <a:buNone/>
               <a:defRPr sz="3075" b="0">
                 <a:solidFill>
                   <a:srgbClr val="132F43"/>
@@ -12713,6 +13131,7 @@
               </a:defRPr>
             </a:lvl7pPr>
             <a:lvl8pPr>
+              <a:buNone/>
               <a:defRPr sz="3075" b="0">
                 <a:solidFill>
                   <a:srgbClr val="132F43"/>
@@ -12723,6 +13142,7 @@
               </a:defRPr>
             </a:lvl8pPr>
             <a:lvl9pPr>
+              <a:buNone/>
               <a:defRPr sz="3075" b="0">
                 <a:solidFill>
                   <a:srgbClr val="132F43"/>
@@ -12735,6 +13155,7 @@
           </a:lstStyle>
           <a:p xmlns:a="http://schemas.openxmlformats.org/drawingml/2006/main">
             <a:pPr>
+              <a:buNone/>
               <a:defRPr sz="3075" b="0">
                 <a:solidFill>
                   <a:srgbClr val="132F43"/>
@@ -12758,6 +13179,7 @@
           </a:p>
           <a:p xmlns:a="http://schemas.openxmlformats.org/drawingml/2006/main">
             <a:pPr>
+              <a:buNone/>
               <a:defRPr sz="3075" b="0">
                 <a:solidFill>
                   <a:srgbClr val="132F43"/>
@@ -12797,8 +13219,8 @@
         </p:nvSpPr>
         <p:spPr>
           <a:xfrm xmlns:a="http://schemas.openxmlformats.org/drawingml/2006/main">
-            <a:off x="1238250" y="36480750"/>
-            <a:ext cx="13239750" cy="1143000"/>
+            <a:off x="1238250" y="36337875"/>
+            <a:ext cx="13239750" cy="1714500"/>
           </a:xfrm>
           <a:prstGeom xmlns:a="http://schemas.openxmlformats.org/drawingml/2006/main" prst="rect">
             <a:avLst/>
@@ -12814,7 +13236,7 @@
           </a:bodyPr>
           <a:lstStyle xmlns:a="http://schemas.openxmlformats.org/drawingml/2006/main">
             <a:defPPr>
-              <a:defRPr sz="2550" b="0">
+              <a:defRPr sz="2400" b="0">
                 <a:solidFill>
                   <a:srgbClr val="4C606E"/>
                 </a:solidFill>
@@ -12824,6 +13246,7 @@
               </a:defRPr>
             </a:defPPr>
             <a:lvl1pPr>
+              <a:buNone/>
               <a:defRPr sz="2550" b="0">
                 <a:solidFill>
                   <a:srgbClr val="4C606E"/>
@@ -12834,6 +13257,7 @@
               </a:defRPr>
             </a:lvl1pPr>
             <a:lvl2pPr>
+              <a:buNone/>
               <a:defRPr sz="2550" b="0">
                 <a:solidFill>
                   <a:srgbClr val="4C606E"/>
@@ -12844,6 +13268,7 @@
               </a:defRPr>
             </a:lvl2pPr>
             <a:lvl3pPr>
+              <a:buNone/>
               <a:defRPr sz="2550" b="0">
                 <a:solidFill>
                   <a:srgbClr val="4C606E"/>
@@ -12854,6 +13279,7 @@
               </a:defRPr>
             </a:lvl3pPr>
             <a:lvl4pPr>
+              <a:buNone/>
               <a:defRPr sz="2550" b="0">
                 <a:solidFill>
                   <a:srgbClr val="4C606E"/>
@@ -12864,6 +13290,7 @@
               </a:defRPr>
             </a:lvl4pPr>
             <a:lvl5pPr>
+              <a:buNone/>
               <a:defRPr sz="2550" b="0">
                 <a:solidFill>
                   <a:srgbClr val="4C606E"/>
@@ -12874,6 +13301,7 @@
               </a:defRPr>
             </a:lvl5pPr>
             <a:lvl6pPr>
+              <a:buNone/>
               <a:defRPr sz="2550" b="0">
                 <a:solidFill>
                   <a:srgbClr val="4C606E"/>
@@ -12884,6 +13312,7 @@
               </a:defRPr>
             </a:lvl6pPr>
             <a:lvl7pPr>
+              <a:buNone/>
               <a:defRPr sz="2550" b="0">
                 <a:solidFill>
                   <a:srgbClr val="4C606E"/>
@@ -12894,6 +13323,7 @@
               </a:defRPr>
             </a:lvl7pPr>
             <a:lvl8pPr>
+              <a:buNone/>
               <a:defRPr sz="2550" b="0">
                 <a:solidFill>
                   <a:srgbClr val="4C606E"/>
@@ -12904,6 +13334,7 @@
               </a:defRPr>
             </a:lvl8pPr>
             <a:lvl9pPr>
+              <a:buNone/>
               <a:defRPr sz="2550" b="0">
                 <a:solidFill>
                   <a:srgbClr val="4C606E"/>
@@ -12916,7 +13347,8 @@
           </a:lstStyle>
           <a:p xmlns:a="http://schemas.openxmlformats.org/drawingml/2006/main">
             <a:pPr>
-              <a:defRPr sz="2550" b="0">
+              <a:buNone/>
+              <a:defRPr sz="2400" b="0">
                 <a:solidFill>
                   <a:srgbClr val="4C606E"/>
                 </a:solidFill>
@@ -12926,7 +13358,7 @@
               </a:defRPr>
             </a:pPr>
             <a:r>
-              <a:rPr sz="2550" b="0">
+              <a:rPr sz="2400" b="0">
                 <a:solidFill>
                   <a:srgbClr val="4C606E"/>
                 </a:solidFill>
@@ -12934,12 +13366,13 @@
                 <a:ea typeface="Malgun Gothic"/>
                 <a:cs typeface="Malgun Gothic"/>
               </a:rPr>
-              <a:t>공식 test 실제 사례: test:000079. 그림은 신체 가속도 3축,</a:t>
+              <a:t>정분류 예시 test:000079(신체 가속도 3축).</a:t>
             </a:r>
           </a:p>
           <a:p xmlns:a="http://schemas.openxmlformats.org/drawingml/2006/main">
             <a:pPr>
-              <a:defRPr sz="2550" b="0">
+              <a:buNone/>
+              <a:defRPr sz="2400" b="0">
                 <a:solidFill>
                   <a:srgbClr val="4C606E"/>
                 </a:solidFill>
@@ -12949,7 +13382,7 @@
               </a:defRPr>
             </a:pPr>
             <a:r>
-              <a:rPr sz="2550" b="0">
+              <a:rPr sz="2400" b="0">
                 <a:solidFill>
                   <a:srgbClr val="4C606E"/>
                 </a:solidFill>
@@ -12957,7 +13390,55 @@
                 <a:ea typeface="Malgun Gothic"/>
                 <a:cs typeface="Malgun Gothic"/>
               </a:rPr>
-              <a:t>분류 입력은 9채널의 평균·표준편차 18개이다.</a:t>
+              <a:t>분류는 9채널 평균·표준편차 18개를 사용한다.</a:t>
+            </a:r>
+          </a:p>
+          <a:p xmlns:a="http://schemas.openxmlformats.org/drawingml/2006/main">
+            <a:pPr>
+              <a:buNone/>
+              <a:defRPr sz="2400" b="0">
+                <a:solidFill>
+                  <a:srgbClr val="4C606E"/>
+                </a:solidFill>
+                <a:latin typeface="Malgun Gothic"/>
+                <a:ea typeface="Malgun Gothic"/>
+                <a:cs typeface="Malgun Gothic"/>
+              </a:defRPr>
+            </a:pPr>
+            <a:r>
+              <a:rPr sz="2400" b="0">
+                <a:solidFill>
+                  <a:srgbClr val="4C606E"/>
+                </a:solidFill>
+                <a:latin typeface="Malgun Gothic"/>
+                <a:ea typeface="Malgun Gothic"/>
+                <a:cs typeface="Malgun Gothic"/>
+              </a:rPr>
+              <a:t>LR3 전체 오류: 2/2,947구간, 사람 9 앉기→이동.</a:t>
+            </a:r>
+          </a:p>
+          <a:p xmlns:a="http://schemas.openxmlformats.org/drawingml/2006/main">
+            <a:pPr>
+              <a:buNone/>
+              <a:defRPr sz="2400" b="0">
+                <a:solidFill>
+                  <a:srgbClr val="4C606E"/>
+                </a:solidFill>
+                <a:latin typeface="Malgun Gothic"/>
+                <a:ea typeface="Malgun Gothic"/>
+                <a:cs typeface="Malgun Gothic"/>
+              </a:defRPr>
+            </a:pPr>
+            <a:r>
+              <a:rPr sz="2400" b="0">
+                <a:solidFill>
+                  <a:srgbClr val="4C606E"/>
+                </a:solidFill>
+                <a:latin typeface="Malgun Gothic"/>
+                <a:ea typeface="Malgun Gothic"/>
+                <a:cs typeface="Malgun Gothic"/>
+              </a:rPr>
+              <a:t>두 오류 구간은 서로 중첩한다.</a:t>
             </a:r>
           </a:p>
         </p:txBody>
@@ -13005,6 +13486,7 @@
               </a:defRPr>
             </a:defPPr>
             <a:lvl1pPr>
+              <a:buNone/>
               <a:defRPr sz="4650" b="1">
                 <a:solidFill>
                   <a:srgbClr val="087F8C"/>
@@ -13015,6 +13497,7 @@
               </a:defRPr>
             </a:lvl1pPr>
             <a:lvl2pPr>
+              <a:buNone/>
               <a:defRPr sz="4650" b="1">
                 <a:solidFill>
                   <a:srgbClr val="087F8C"/>
@@ -13025,6 +13508,7 @@
               </a:defRPr>
             </a:lvl2pPr>
             <a:lvl3pPr>
+              <a:buNone/>
               <a:defRPr sz="4650" b="1">
                 <a:solidFill>
                   <a:srgbClr val="087F8C"/>
@@ -13035,6 +13519,7 @@
               </a:defRPr>
             </a:lvl3pPr>
             <a:lvl4pPr>
+              <a:buNone/>
               <a:defRPr sz="4650" b="1">
                 <a:solidFill>
                   <a:srgbClr val="087F8C"/>
@@ -13045,6 +13530,7 @@
               </a:defRPr>
             </a:lvl4pPr>
             <a:lvl5pPr>
+              <a:buNone/>
               <a:defRPr sz="4650" b="1">
                 <a:solidFill>
                   <a:srgbClr val="087F8C"/>
@@ -13055,6 +13541,7 @@
               </a:defRPr>
             </a:lvl5pPr>
             <a:lvl6pPr>
+              <a:buNone/>
               <a:defRPr sz="4650" b="1">
                 <a:solidFill>
                   <a:srgbClr val="087F8C"/>
@@ -13065,6 +13552,7 @@
               </a:defRPr>
             </a:lvl6pPr>
             <a:lvl7pPr>
+              <a:buNone/>
               <a:defRPr sz="4650" b="1">
                 <a:solidFill>
                   <a:srgbClr val="087F8C"/>
@@ -13075,6 +13563,7 @@
               </a:defRPr>
             </a:lvl7pPr>
             <a:lvl8pPr>
+              <a:buNone/>
               <a:defRPr sz="4650" b="1">
                 <a:solidFill>
                   <a:srgbClr val="087F8C"/>
@@ -13085,6 +13574,7 @@
               </a:defRPr>
             </a:lvl8pPr>
             <a:lvl9pPr>
+              <a:buNone/>
               <a:defRPr sz="4650" b="1">
                 <a:solidFill>
                   <a:srgbClr val="087F8C"/>
@@ -13097,6 +13587,7 @@
           </a:lstStyle>
           <a:p xmlns:a="http://schemas.openxmlformats.org/drawingml/2006/main">
             <a:pPr>
+              <a:buNone/>
               <a:defRPr sz="4650" b="1">
                 <a:solidFill>
                   <a:srgbClr val="087F8C"/>
@@ -13153,7 +13644,7 @@
           </a:bodyPr>
           <a:lstStyle xmlns:a="http://schemas.openxmlformats.org/drawingml/2006/main">
             <a:defPPr>
-              <a:defRPr sz="3900" b="1">
+              <a:defRPr sz="3675" b="1">
                 <a:solidFill>
                   <a:srgbClr val="132F43"/>
                 </a:solidFill>
@@ -13163,6 +13654,7 @@
               </a:defRPr>
             </a:defPPr>
             <a:lvl1pPr>
+              <a:buNone/>
               <a:defRPr sz="3900" b="1">
                 <a:solidFill>
                   <a:srgbClr val="132F43"/>
@@ -13173,6 +13665,7 @@
               </a:defRPr>
             </a:lvl1pPr>
             <a:lvl2pPr>
+              <a:buNone/>
               <a:defRPr sz="3900" b="1">
                 <a:solidFill>
                   <a:srgbClr val="132F43"/>
@@ -13183,6 +13676,7 @@
               </a:defRPr>
             </a:lvl2pPr>
             <a:lvl3pPr>
+              <a:buNone/>
               <a:defRPr sz="3900" b="1">
                 <a:solidFill>
                   <a:srgbClr val="132F43"/>
@@ -13193,6 +13687,7 @@
               </a:defRPr>
             </a:lvl3pPr>
             <a:lvl4pPr>
+              <a:buNone/>
               <a:defRPr sz="3900" b="1">
                 <a:solidFill>
                   <a:srgbClr val="132F43"/>
@@ -13203,6 +13698,7 @@
               </a:defRPr>
             </a:lvl4pPr>
             <a:lvl5pPr>
+              <a:buNone/>
               <a:defRPr sz="3900" b="1">
                 <a:solidFill>
                   <a:srgbClr val="132F43"/>
@@ -13213,6 +13709,7 @@
               </a:defRPr>
             </a:lvl5pPr>
             <a:lvl6pPr>
+              <a:buNone/>
               <a:defRPr sz="3900" b="1">
                 <a:solidFill>
                   <a:srgbClr val="132F43"/>
@@ -13223,6 +13720,7 @@
               </a:defRPr>
             </a:lvl6pPr>
             <a:lvl7pPr>
+              <a:buNone/>
               <a:defRPr sz="3900" b="1">
                 <a:solidFill>
                   <a:srgbClr val="132F43"/>
@@ -13233,6 +13731,7 @@
               </a:defRPr>
             </a:lvl7pPr>
             <a:lvl8pPr>
+              <a:buNone/>
               <a:defRPr sz="3900" b="1">
                 <a:solidFill>
                   <a:srgbClr val="132F43"/>
@@ -13243,6 +13742,7 @@
               </a:defRPr>
             </a:lvl8pPr>
             <a:lvl9pPr>
+              <a:buNone/>
               <a:defRPr sz="3900" b="1">
                 <a:solidFill>
                   <a:srgbClr val="132F43"/>
@@ -13255,7 +13755,8 @@
           </a:lstStyle>
           <a:p xmlns:a="http://schemas.openxmlformats.org/drawingml/2006/main">
             <a:pPr>
-              <a:defRPr sz="3900" b="1">
+              <a:buNone/>
+              <a:defRPr sz="3675" b="1">
                 <a:solidFill>
                   <a:srgbClr val="132F43"/>
                 </a:solidFill>
@@ -13265,7 +13766,7 @@
               </a:defRPr>
             </a:pPr>
             <a:r>
-              <a:rPr sz="3900" b="1">
+              <a:rPr sz="3675" b="1">
                 <a:solidFill>
                   <a:srgbClr val="132F43"/>
                 </a:solidFill>
@@ -13273,7 +13774,7 @@
                 <a:ea typeface="Malgun Gothic"/>
                 <a:cs typeface="Malgun Gothic"/>
               </a:rPr>
-              <a:t>활동 상태 표시·구간별 태그</a:t>
+              <a:t>활동 일지의 구간별 상태 표시</a:t>
             </a:r>
           </a:p>
         </p:txBody>
@@ -13295,7 +13796,7 @@
         <p:spPr>
           <a:xfrm xmlns:a="http://schemas.openxmlformats.org/drawingml/2006/main">
             <a:off x="15716250" y="33385125"/>
-            <a:ext cx="13321500" cy="1304925"/>
+            <a:ext cx="13321475" cy="1285875"/>
           </a:xfrm>
           <a:prstGeom xmlns:a="http://schemas.openxmlformats.org/drawingml/2006/main" prst="rect">
             <a:avLst/>
@@ -13311,7 +13812,7 @@
           </a:bodyPr>
           <a:lstStyle xmlns:a="http://schemas.openxmlformats.org/drawingml/2006/main">
             <a:defPPr>
-              <a:defRPr sz="3225" b="0">
+              <a:defRPr sz="2850" b="0">
                 <a:solidFill>
                   <a:srgbClr val="132F43"/>
                 </a:solidFill>
@@ -13321,6 +13822,7 @@
               </a:defRPr>
             </a:defPPr>
             <a:lvl1pPr>
+              <a:buNone/>
               <a:defRPr sz="3225" b="0">
                 <a:solidFill>
                   <a:srgbClr val="132F43"/>
@@ -13331,6 +13833,7 @@
               </a:defRPr>
             </a:lvl1pPr>
             <a:lvl2pPr>
+              <a:buNone/>
               <a:defRPr sz="3225" b="0">
                 <a:solidFill>
                   <a:srgbClr val="132F43"/>
@@ -13341,6 +13844,7 @@
               </a:defRPr>
             </a:lvl2pPr>
             <a:lvl3pPr>
+              <a:buNone/>
               <a:defRPr sz="3225" b="0">
                 <a:solidFill>
                   <a:srgbClr val="132F43"/>
@@ -13351,6 +13855,7 @@
               </a:defRPr>
             </a:lvl3pPr>
             <a:lvl4pPr>
+              <a:buNone/>
               <a:defRPr sz="3225" b="0">
                 <a:solidFill>
                   <a:srgbClr val="132F43"/>
@@ -13361,6 +13866,7 @@
               </a:defRPr>
             </a:lvl4pPr>
             <a:lvl5pPr>
+              <a:buNone/>
               <a:defRPr sz="3225" b="0">
                 <a:solidFill>
                   <a:srgbClr val="132F43"/>
@@ -13371,6 +13877,7 @@
               </a:defRPr>
             </a:lvl5pPr>
             <a:lvl6pPr>
+              <a:buNone/>
               <a:defRPr sz="3225" b="0">
                 <a:solidFill>
                   <a:srgbClr val="132F43"/>
@@ -13381,6 +13888,7 @@
               </a:defRPr>
             </a:lvl6pPr>
             <a:lvl7pPr>
+              <a:buNone/>
               <a:defRPr sz="3225" b="0">
                 <a:solidFill>
                   <a:srgbClr val="132F43"/>
@@ -13391,6 +13899,7 @@
               </a:defRPr>
             </a:lvl7pPr>
             <a:lvl8pPr>
+              <a:buNone/>
               <a:defRPr sz="3225" b="0">
                 <a:solidFill>
                   <a:srgbClr val="132F43"/>
@@ -13401,6 +13910,7 @@
               </a:defRPr>
             </a:lvl8pPr>
             <a:lvl9pPr>
+              <a:buNone/>
               <a:defRPr sz="3225" b="0">
                 <a:solidFill>
                   <a:srgbClr val="132F43"/>
@@ -13413,7 +13923,8 @@
           </a:lstStyle>
           <a:p xmlns:a="http://schemas.openxmlformats.org/drawingml/2006/main">
             <a:pPr>
-              <a:defRPr sz="3225" b="0">
+              <a:buNone/>
+              <a:defRPr sz="2850" b="0">
                 <a:solidFill>
                   <a:srgbClr val="132F43"/>
                 </a:solidFill>
@@ -13423,7 +13934,7 @@
               </a:defRPr>
             </a:pPr>
             <a:r>
-              <a:rPr sz="3225" b="0">
+              <a:rPr sz="2850" b="0">
                 <a:solidFill>
                   <a:srgbClr val="132F43"/>
                 </a:solidFill>
@@ -13431,12 +13942,13 @@
                 <a:ea typeface="Malgun Gothic"/>
                 <a:cs typeface="Malgun Gothic"/>
               </a:rPr>
-              <a:t>카메라·GPS 없이 3상태 태그를 생성하는 구성은</a:t>
+              <a:t>카메라·GPS 없이 이동·앉거나 서 있음·누워 있음 태그.</a:t>
             </a:r>
           </a:p>
           <a:p xmlns:a="http://schemas.openxmlformats.org/drawingml/2006/main">
             <a:pPr>
-              <a:defRPr sz="3225" b="0">
+              <a:buNone/>
+              <a:defRPr sz="2850" b="0">
                 <a:solidFill>
                   <a:srgbClr val="132F43"/>
                 </a:solidFill>
@@ -13446,7 +13958,7 @@
               </a:defRPr>
             </a:pPr>
             <a:r>
-              <a:rPr sz="3225" b="0">
+              <a:rPr sz="2850" b="0">
                 <a:solidFill>
                   <a:srgbClr val="132F43"/>
                 </a:solidFill>
@@ -13454,7 +13966,7 @@
                 <a:ea typeface="Malgun Gothic"/>
                 <a:cs typeface="Malgun Gothic"/>
               </a:rPr>
-              <a:t>높은 F1을 보인 모델의 비용을 함께 검토한다.</a:t>
+              <a:t>요약 목표에는 높은 F1을 보인 구성의 비용을 비교한다.</a:t>
             </a:r>
           </a:p>
         </p:txBody>
@@ -13492,7 +14004,7 @@
           </a:bodyPr>
           <a:lstStyle xmlns:a="http://schemas.openxmlformats.org/drawingml/2006/main">
             <a:defPPr>
-              <a:defRPr sz="3900" b="1">
+              <a:defRPr sz="3675" b="1">
                 <a:solidFill>
                   <a:srgbClr val="132F43"/>
                 </a:solidFill>
@@ -13502,6 +14014,7 @@
               </a:defRPr>
             </a:defPPr>
             <a:lvl1pPr>
+              <a:buNone/>
               <a:defRPr sz="3900" b="1">
                 <a:solidFill>
                   <a:srgbClr val="132F43"/>
@@ -13512,6 +14025,7 @@
               </a:defRPr>
             </a:lvl1pPr>
             <a:lvl2pPr>
+              <a:buNone/>
               <a:defRPr sz="3900" b="1">
                 <a:solidFill>
                   <a:srgbClr val="132F43"/>
@@ -13522,6 +14036,7 @@
               </a:defRPr>
             </a:lvl2pPr>
             <a:lvl3pPr>
+              <a:buNone/>
               <a:defRPr sz="3900" b="1">
                 <a:solidFill>
                   <a:srgbClr val="132F43"/>
@@ -13532,6 +14047,7 @@
               </a:defRPr>
             </a:lvl3pPr>
             <a:lvl4pPr>
+              <a:buNone/>
               <a:defRPr sz="3900" b="1">
                 <a:solidFill>
                   <a:srgbClr val="132F43"/>
@@ -13542,6 +14058,7 @@
               </a:defRPr>
             </a:lvl4pPr>
             <a:lvl5pPr>
+              <a:buNone/>
               <a:defRPr sz="3900" b="1">
                 <a:solidFill>
                   <a:srgbClr val="132F43"/>
@@ -13552,6 +14069,7 @@
               </a:defRPr>
             </a:lvl5pPr>
             <a:lvl6pPr>
+              <a:buNone/>
               <a:defRPr sz="3900" b="1">
                 <a:solidFill>
                   <a:srgbClr val="132F43"/>
@@ -13562,6 +14080,7 @@
               </a:defRPr>
             </a:lvl6pPr>
             <a:lvl7pPr>
+              <a:buNone/>
               <a:defRPr sz="3900" b="1">
                 <a:solidFill>
                   <a:srgbClr val="132F43"/>
@@ -13572,6 +14091,7 @@
               </a:defRPr>
             </a:lvl7pPr>
             <a:lvl8pPr>
+              <a:buNone/>
               <a:defRPr sz="3900" b="1">
                 <a:solidFill>
                   <a:srgbClr val="132F43"/>
@@ -13582,6 +14102,7 @@
               </a:defRPr>
             </a:lvl8pPr>
             <a:lvl9pPr>
+              <a:buNone/>
               <a:defRPr sz="3900" b="1">
                 <a:solidFill>
                   <a:srgbClr val="132F43"/>
@@ -13594,7 +14115,8 @@
           </a:lstStyle>
           <a:p xmlns:a="http://schemas.openxmlformats.org/drawingml/2006/main">
             <a:pPr>
-              <a:defRPr sz="3900" b="1">
+              <a:buNone/>
+              <a:defRPr sz="3675" b="1">
                 <a:solidFill>
                   <a:srgbClr val="132F43"/>
                 </a:solidFill>
@@ -13604,7 +14126,7 @@
               </a:defRPr>
             </a:pPr>
             <a:r>
-              <a:rPr sz="3900" b="1">
+              <a:rPr sz="3675" b="1">
                 <a:solidFill>
                   <a:srgbClr val="132F43"/>
                 </a:solidFill>
@@ -13612,7 +14134,7 @@
                 <a:ea typeface="Malgun Gothic"/>
                 <a:cs typeface="Malgun Gothic"/>
               </a:rPr>
-              <a:t>좌식·계단 이용 기록</a:t>
+              <a:t>좌식·계단 이용의 세부 기록</a:t>
             </a:r>
           </a:p>
         </p:txBody>
@@ -13634,7 +14156,7 @@
         <p:spPr>
           <a:xfrm xmlns:a="http://schemas.openxmlformats.org/drawingml/2006/main">
             <a:off x="15716250" y="35861625"/>
-            <a:ext cx="13321500" cy="1285875"/>
+            <a:ext cx="13321475" cy="1238250"/>
           </a:xfrm>
           <a:prstGeom xmlns:a="http://schemas.openxmlformats.org/drawingml/2006/main" prst="rect">
             <a:avLst/>
@@ -13650,7 +14172,7 @@
           </a:bodyPr>
           <a:lstStyle xmlns:a="http://schemas.openxmlformats.org/drawingml/2006/main">
             <a:defPPr>
-              <a:defRPr sz="3225" b="0">
+              <a:defRPr sz="3000" b="0">
                 <a:solidFill>
                   <a:srgbClr val="132F43"/>
                 </a:solidFill>
@@ -13660,6 +14182,7 @@
               </a:defRPr>
             </a:defPPr>
             <a:lvl1pPr>
+              <a:buNone/>
               <a:defRPr sz="3225" b="0">
                 <a:solidFill>
                   <a:srgbClr val="132F43"/>
@@ -13670,6 +14193,7 @@
               </a:defRPr>
             </a:lvl1pPr>
             <a:lvl2pPr>
+              <a:buNone/>
               <a:defRPr sz="3225" b="0">
                 <a:solidFill>
                   <a:srgbClr val="132F43"/>
@@ -13680,6 +14204,7 @@
               </a:defRPr>
             </a:lvl2pPr>
             <a:lvl3pPr>
+              <a:buNone/>
               <a:defRPr sz="3225" b="0">
                 <a:solidFill>
                   <a:srgbClr val="132F43"/>
@@ -13690,6 +14215,7 @@
               </a:defRPr>
             </a:lvl3pPr>
             <a:lvl4pPr>
+              <a:buNone/>
               <a:defRPr sz="3225" b="0">
                 <a:solidFill>
                   <a:srgbClr val="132F43"/>
@@ -13700,6 +14226,7 @@
               </a:defRPr>
             </a:lvl4pPr>
             <a:lvl5pPr>
+              <a:buNone/>
               <a:defRPr sz="3225" b="0">
                 <a:solidFill>
                   <a:srgbClr val="132F43"/>
@@ -13710,6 +14237,7 @@
               </a:defRPr>
             </a:lvl5pPr>
             <a:lvl6pPr>
+              <a:buNone/>
               <a:defRPr sz="3225" b="0">
                 <a:solidFill>
                   <a:srgbClr val="132F43"/>
@@ -13720,6 +14248,7 @@
               </a:defRPr>
             </a:lvl6pPr>
             <a:lvl7pPr>
+              <a:buNone/>
               <a:defRPr sz="3225" b="0">
                 <a:solidFill>
                   <a:srgbClr val="132F43"/>
@@ -13730,6 +14259,7 @@
               </a:defRPr>
             </a:lvl7pPr>
             <a:lvl8pPr>
+              <a:buNone/>
               <a:defRPr sz="3225" b="0">
                 <a:solidFill>
                   <a:srgbClr val="132F43"/>
@@ -13740,6 +14270,7 @@
               </a:defRPr>
             </a:lvl8pPr>
             <a:lvl9pPr>
+              <a:buNone/>
               <a:defRPr sz="3225" b="0">
                 <a:solidFill>
                   <a:srgbClr val="132F43"/>
@@ -13752,7 +14283,8 @@
           </a:lstStyle>
           <a:p xmlns:a="http://schemas.openxmlformats.org/drawingml/2006/main">
             <a:pPr>
-              <a:defRPr sz="3225" b="0">
+              <a:buNone/>
+              <a:defRPr sz="3000" b="0">
                 <a:solidFill>
                   <a:srgbClr val="132F43"/>
                 </a:solidFill>
@@ -13762,7 +14294,7 @@
               </a:defRPr>
             </a:pPr>
             <a:r>
-              <a:rPr sz="3225" b="0">
+              <a:rPr sz="3000" b="0">
                 <a:solidFill>
                   <a:srgbClr val="132F43"/>
                 </a:solidFill>
@@ -13770,12 +14302,13 @@
                 <a:ea typeface="Malgun Gothic"/>
                 <a:cs typeface="Malgun Gothic"/>
               </a:rPr>
-              <a:t>앉기·서기와 이동 세부 라벨을 유지한다.</a:t>
+              <a:t>앉기·서기, 걷기·오르기·내리기 라벨을 보존한다.</a:t>
             </a:r>
           </a:p>
           <a:p xmlns:a="http://schemas.openxmlformats.org/drawingml/2006/main">
             <a:pPr>
-              <a:defRPr sz="3225" b="0">
+              <a:buNone/>
+              <a:defRPr sz="3000" b="0">
                 <a:solidFill>
                   <a:srgbClr val="132F43"/>
                 </a:solidFill>
@@ -13785,7 +14318,7 @@
               </a:defRPr>
             </a:pPr>
             <a:r>
-              <a:rPr sz="3225" b="0">
+              <a:rPr sz="3000" b="0">
                 <a:solidFill>
                   <a:srgbClr val="132F43"/>
                 </a:solidFill>
@@ -13814,8 +14347,8 @@
         </p:nvSpPr>
         <p:spPr>
           <a:xfrm xmlns:a="http://schemas.openxmlformats.org/drawingml/2006/main">
-            <a:off x="15716250" y="37338000"/>
-            <a:ext cx="13321500" cy="933450"/>
+            <a:off x="15716250" y="37242750"/>
+            <a:ext cx="13321475" cy="857250"/>
           </a:xfrm>
           <a:prstGeom xmlns:a="http://schemas.openxmlformats.org/drawingml/2006/main" prst="rect">
             <a:avLst/>
@@ -13831,7 +14364,7 @@
           </a:bodyPr>
           <a:lstStyle xmlns:a="http://schemas.openxmlformats.org/drawingml/2006/main">
             <a:defPPr>
-              <a:defRPr sz="2475" b="0">
+              <a:defRPr sz="2325" b="0">
                 <a:solidFill>
                   <a:srgbClr val="4C606E"/>
                 </a:solidFill>
@@ -13841,6 +14374,7 @@
               </a:defRPr>
             </a:defPPr>
             <a:lvl1pPr>
+              <a:buNone/>
               <a:defRPr sz="2475" b="0">
                 <a:solidFill>
                   <a:srgbClr val="4C606E"/>
@@ -13851,6 +14385,7 @@
               </a:defRPr>
             </a:lvl1pPr>
             <a:lvl2pPr>
+              <a:buNone/>
               <a:defRPr sz="2475" b="0">
                 <a:solidFill>
                   <a:srgbClr val="4C606E"/>
@@ -13861,6 +14396,7 @@
               </a:defRPr>
             </a:lvl2pPr>
             <a:lvl3pPr>
+              <a:buNone/>
               <a:defRPr sz="2475" b="0">
                 <a:solidFill>
                   <a:srgbClr val="4C606E"/>
@@ -13871,6 +14407,7 @@
               </a:defRPr>
             </a:lvl3pPr>
             <a:lvl4pPr>
+              <a:buNone/>
               <a:defRPr sz="2475" b="0">
                 <a:solidFill>
                   <a:srgbClr val="4C606E"/>
@@ -13881,6 +14418,7 @@
               </a:defRPr>
             </a:lvl4pPr>
             <a:lvl5pPr>
+              <a:buNone/>
               <a:defRPr sz="2475" b="0">
                 <a:solidFill>
                   <a:srgbClr val="4C606E"/>
@@ -13891,6 +14429,7 @@
               </a:defRPr>
             </a:lvl5pPr>
             <a:lvl6pPr>
+              <a:buNone/>
               <a:defRPr sz="2475" b="0">
                 <a:solidFill>
                   <a:srgbClr val="4C606E"/>
@@ -13901,6 +14440,7 @@
               </a:defRPr>
             </a:lvl6pPr>
             <a:lvl7pPr>
+              <a:buNone/>
               <a:defRPr sz="2475" b="0">
                 <a:solidFill>
                   <a:srgbClr val="4C606E"/>
@@ -13911,6 +14451,7 @@
               </a:defRPr>
             </a:lvl7pPr>
             <a:lvl8pPr>
+              <a:buNone/>
               <a:defRPr sz="2475" b="0">
                 <a:solidFill>
                   <a:srgbClr val="4C606E"/>
@@ -13921,6 +14462,7 @@
               </a:defRPr>
             </a:lvl8pPr>
             <a:lvl9pPr>
+              <a:buNone/>
               <a:defRPr sz="2475" b="0">
                 <a:solidFill>
                   <a:srgbClr val="4C606E"/>
@@ -13933,7 +14475,8 @@
           </a:lstStyle>
           <a:p xmlns:a="http://schemas.openxmlformats.org/drawingml/2006/main">
             <a:pPr>
-              <a:defRPr sz="2475" b="0">
+              <a:buNone/>
+              <a:defRPr sz="2325" b="0">
                 <a:solidFill>
                   <a:srgbClr val="4C606E"/>
                 </a:solidFill>
@@ -13943,7 +14486,7 @@
               </a:defRPr>
             </a:pPr>
             <a:r>
-              <a:rPr sz="2475" b="0">
+              <a:rPr sz="2325" b="0">
                 <a:solidFill>
                   <a:srgbClr val="4C606E"/>
                 </a:solidFill>
@@ -13951,7 +14494,31 @@
                 <a:ea typeface="Malgun Gothic"/>
                 <a:cs typeface="Malgun Gothic"/>
               </a:rPr>
-              <a:t>평가 범위: 허리 착용 6동작. 누워 있음은 자세 라벨이다.</a:t>
+              <a:t>활용은 구간별 출력 설계이다. 허리 착용 6동작을 평가했고,</a:t>
+            </a:r>
+          </a:p>
+          <a:p xmlns:a="http://schemas.openxmlformats.org/drawingml/2006/main">
+            <a:pPr>
+              <a:buNone/>
+              <a:defRPr sz="2325" b="0">
+                <a:solidFill>
+                  <a:srgbClr val="4C606E"/>
+                </a:solidFill>
+                <a:latin typeface="Malgun Gothic"/>
+                <a:ea typeface="Malgun Gothic"/>
+                <a:cs typeface="Malgun Gothic"/>
+              </a:defRPr>
+            </a:pPr>
+            <a:r>
+              <a:rPr sz="2325" b="0">
+                <a:solidFill>
+                  <a:srgbClr val="4C606E"/>
+                </a:solidFill>
+                <a:latin typeface="Malgun Gothic"/>
+                <a:ea typeface="Malgun Gothic"/>
+                <a:cs typeface="Malgun Gothic"/>
+              </a:rPr>
+              <a:t>누워 있음은 자세 라벨이다.</a:t>
             </a:r>
           </a:p>
         </p:txBody>
@@ -13999,6 +14566,7 @@
               </a:defRPr>
             </a:defPPr>
             <a:lvl1pPr>
+              <a:buNone/>
               <a:defRPr sz="2250" b="0">
                 <a:solidFill>
                   <a:srgbClr val="4C606E"/>
@@ -14009,6 +14577,7 @@
               </a:defRPr>
             </a:lvl1pPr>
             <a:lvl2pPr>
+              <a:buNone/>
               <a:defRPr sz="2250" b="0">
                 <a:solidFill>
                   <a:srgbClr val="4C606E"/>
@@ -14019,6 +14588,7 @@
               </a:defRPr>
             </a:lvl2pPr>
             <a:lvl3pPr>
+              <a:buNone/>
               <a:defRPr sz="2250" b="0">
                 <a:solidFill>
                   <a:srgbClr val="4C606E"/>
@@ -14029,6 +14599,7 @@
               </a:defRPr>
             </a:lvl3pPr>
             <a:lvl4pPr>
+              <a:buNone/>
               <a:defRPr sz="2250" b="0">
                 <a:solidFill>
                   <a:srgbClr val="4C606E"/>
@@ -14039,6 +14610,7 @@
               </a:defRPr>
             </a:lvl4pPr>
             <a:lvl5pPr>
+              <a:buNone/>
               <a:defRPr sz="2250" b="0">
                 <a:solidFill>
                   <a:srgbClr val="4C606E"/>
@@ -14049,6 +14621,7 @@
               </a:defRPr>
             </a:lvl5pPr>
             <a:lvl6pPr>
+              <a:buNone/>
               <a:defRPr sz="2250" b="0">
                 <a:solidFill>
                   <a:srgbClr val="4C606E"/>
@@ -14059,6 +14632,7 @@
               </a:defRPr>
             </a:lvl6pPr>
             <a:lvl7pPr>
+              <a:buNone/>
               <a:defRPr sz="2250" b="0">
                 <a:solidFill>
                   <a:srgbClr val="4C606E"/>
@@ -14069,6 +14643,7 @@
               </a:defRPr>
             </a:lvl7pPr>
             <a:lvl8pPr>
+              <a:buNone/>
               <a:defRPr sz="2250" b="0">
                 <a:solidFill>
                   <a:srgbClr val="4C606E"/>
@@ -14079,6 +14654,7 @@
               </a:defRPr>
             </a:lvl8pPr>
             <a:lvl9pPr>
+              <a:buNone/>
               <a:defRPr sz="2250" b="0">
                 <a:solidFill>
                   <a:srgbClr val="4C606E"/>
@@ -14091,6 +14667,7 @@
           </a:lstStyle>
           <a:p xmlns:a="http://schemas.openxmlformats.org/drawingml/2006/main">
             <a:pPr>
+              <a:buNone/>
               <a:defRPr sz="2250" b="0">
                 <a:solidFill>
                   <a:srgbClr val="4C606E"/>
@@ -14114,6 +14691,7 @@
           </a:p>
           <a:p xmlns:a="http://schemas.openxmlformats.org/drawingml/2006/main">
             <a:pPr>
+              <a:buNone/>
               <a:defRPr sz="2250" b="0">
                 <a:solidFill>
                   <a:srgbClr val="4C606E"/>
@@ -14180,6 +14758,7 @@
               </a:defRPr>
             </a:defPPr>
             <a:lvl1pPr>
+              <a:buNone/>
               <a:defRPr sz="2250" b="0">
                 <a:solidFill>
                   <a:srgbClr val="4C606E"/>
@@ -14190,6 +14769,7 @@
               </a:defRPr>
             </a:lvl1pPr>
             <a:lvl2pPr>
+              <a:buNone/>
               <a:defRPr sz="2250" b="0">
                 <a:solidFill>
                   <a:srgbClr val="4C606E"/>
@@ -14200,6 +14780,7 @@
               </a:defRPr>
             </a:lvl2pPr>
             <a:lvl3pPr>
+              <a:buNone/>
               <a:defRPr sz="2250" b="0">
                 <a:solidFill>
                   <a:srgbClr val="4C606E"/>
@@ -14210,6 +14791,7 @@
               </a:defRPr>
             </a:lvl3pPr>
             <a:lvl4pPr>
+              <a:buNone/>
               <a:defRPr sz="2250" b="0">
                 <a:solidFill>
                   <a:srgbClr val="4C606E"/>
@@ -14220,6 +14802,7 @@
               </a:defRPr>
             </a:lvl4pPr>
             <a:lvl5pPr>
+              <a:buNone/>
               <a:defRPr sz="2250" b="0">
                 <a:solidFill>
                   <a:srgbClr val="4C606E"/>
@@ -14230,6 +14813,7 @@
               </a:defRPr>
             </a:lvl5pPr>
             <a:lvl6pPr>
+              <a:buNone/>
               <a:defRPr sz="2250" b="0">
                 <a:solidFill>
                   <a:srgbClr val="4C606E"/>
@@ -14240,6 +14824,7 @@
               </a:defRPr>
             </a:lvl6pPr>
             <a:lvl7pPr>
+              <a:buNone/>
               <a:defRPr sz="2250" b="0">
                 <a:solidFill>
                   <a:srgbClr val="4C606E"/>
@@ -14250,6 +14835,7 @@
               </a:defRPr>
             </a:lvl7pPr>
             <a:lvl8pPr>
+              <a:buNone/>
               <a:defRPr sz="2250" b="0">
                 <a:solidFill>
                   <a:srgbClr val="4C606E"/>
@@ -14260,6 +14846,7 @@
               </a:defRPr>
             </a:lvl8pPr>
             <a:lvl9pPr>
+              <a:buNone/>
               <a:defRPr sz="2250" b="0">
                 <a:solidFill>
                   <a:srgbClr val="4C606E"/>
@@ -14272,6 +14859,7 @@
           </a:lstStyle>
           <a:p xmlns:a="http://schemas.openxmlformats.org/drawingml/2006/main">
             <a:pPr>
+              <a:buNone/>
               <a:defRPr sz="2250" b="0">
                 <a:solidFill>
                   <a:srgbClr val="4C606E"/>
@@ -14295,6 +14883,7 @@
           </a:p>
           <a:p xmlns:a="http://schemas.openxmlformats.org/drawingml/2006/main">
             <a:pPr>
+              <a:buNone/>
               <a:defRPr sz="2250" b="0">
                 <a:solidFill>
                   <a:srgbClr val="4C606E"/>
@@ -14361,6 +14950,7 @@
               </a:defRPr>
             </a:defPPr>
             <a:lvl1pPr>
+              <a:buNone/>
               <a:defRPr sz="2100" b="0">
                 <a:solidFill>
                   <a:srgbClr val="4C606E"/>
@@ -14371,6 +14961,7 @@
               </a:defRPr>
             </a:lvl1pPr>
             <a:lvl2pPr>
+              <a:buNone/>
               <a:defRPr sz="2100" b="0">
                 <a:solidFill>
                   <a:srgbClr val="4C606E"/>
@@ -14381,6 +14972,7 @@
               </a:defRPr>
             </a:lvl2pPr>
             <a:lvl3pPr>
+              <a:buNone/>
               <a:defRPr sz="2100" b="0">
                 <a:solidFill>
                   <a:srgbClr val="4C606E"/>
@@ -14391,6 +14983,7 @@
               </a:defRPr>
             </a:lvl3pPr>
             <a:lvl4pPr>
+              <a:buNone/>
               <a:defRPr sz="2100" b="0">
                 <a:solidFill>
                   <a:srgbClr val="4C606E"/>
@@ -14401,6 +14994,7 @@
               </a:defRPr>
             </a:lvl4pPr>
             <a:lvl5pPr>
+              <a:buNone/>
               <a:defRPr sz="2100" b="0">
                 <a:solidFill>
                   <a:srgbClr val="4C606E"/>
@@ -14411,6 +15005,7 @@
               </a:defRPr>
             </a:lvl5pPr>
             <a:lvl6pPr>
+              <a:buNone/>
               <a:defRPr sz="2100" b="0">
                 <a:solidFill>
                   <a:srgbClr val="4C606E"/>
@@ -14421,6 +15016,7 @@
               </a:defRPr>
             </a:lvl6pPr>
             <a:lvl7pPr>
+              <a:buNone/>
               <a:defRPr sz="2100" b="0">
                 <a:solidFill>
                   <a:srgbClr val="4C606E"/>
@@ -14431,6 +15027,7 @@
               </a:defRPr>
             </a:lvl7pPr>
             <a:lvl8pPr>
+              <a:buNone/>
               <a:defRPr sz="2100" b="0">
                 <a:solidFill>
                   <a:srgbClr val="4C606E"/>
@@ -14441,6 +15038,7 @@
               </a:defRPr>
             </a:lvl8pPr>
             <a:lvl9pPr>
+              <a:buNone/>
               <a:defRPr sz="2100" b="0">
                 <a:solidFill>
                   <a:srgbClr val="4C606E"/>
@@ -14453,6 +15051,7 @@
           </a:lstStyle>
           <a:p xmlns:a="http://schemas.openxmlformats.org/drawingml/2006/main">
             <a:pPr>
+              <a:buNone/>
               <a:defRPr sz="2100" b="0">
                 <a:solidFill>
                   <a:srgbClr val="4C606E"/>
@@ -14476,6 +15075,7 @@
           </a:p>
           <a:p xmlns:a="http://schemas.openxmlformats.org/drawingml/2006/main">
             <a:pPr>
+              <a:buNone/>
               <a:defRPr sz="2100" b="0">
                 <a:solidFill>
                   <a:srgbClr val="4C606E"/>
@@ -14542,6 +15142,7 @@
               </a:defRPr>
             </a:defPPr>
             <a:lvl1pPr>
+              <a:buNone/>
               <a:defRPr sz="1950" b="0">
                 <a:solidFill>
                   <a:srgbClr val="4C606E"/>
@@ -14552,6 +15153,7 @@
               </a:defRPr>
             </a:lvl1pPr>
             <a:lvl2pPr>
+              <a:buNone/>
               <a:defRPr sz="1950" b="0">
                 <a:solidFill>
                   <a:srgbClr val="4C606E"/>
@@ -14562,6 +15164,7 @@
               </a:defRPr>
             </a:lvl2pPr>
             <a:lvl3pPr>
+              <a:buNone/>
               <a:defRPr sz="1950" b="0">
                 <a:solidFill>
                   <a:srgbClr val="4C606E"/>
@@ -14572,6 +15175,7 @@
               </a:defRPr>
             </a:lvl3pPr>
             <a:lvl4pPr>
+              <a:buNone/>
               <a:defRPr sz="1950" b="0">
                 <a:solidFill>
                   <a:srgbClr val="4C606E"/>
@@ -14582,6 +15186,7 @@
               </a:defRPr>
             </a:lvl4pPr>
             <a:lvl5pPr>
+              <a:buNone/>
               <a:defRPr sz="1950" b="0">
                 <a:solidFill>
                   <a:srgbClr val="4C606E"/>
@@ -14592,6 +15197,7 @@
               </a:defRPr>
             </a:lvl5pPr>
             <a:lvl6pPr>
+              <a:buNone/>
               <a:defRPr sz="1950" b="0">
                 <a:solidFill>
                   <a:srgbClr val="4C606E"/>
@@ -14602,6 +15208,7 @@
               </a:defRPr>
             </a:lvl6pPr>
             <a:lvl7pPr>
+              <a:buNone/>
               <a:defRPr sz="1950" b="0">
                 <a:solidFill>
                   <a:srgbClr val="4C606E"/>
@@ -14612,6 +15219,7 @@
               </a:defRPr>
             </a:lvl7pPr>
             <a:lvl8pPr>
+              <a:buNone/>
               <a:defRPr sz="1950" b="0">
                 <a:solidFill>
                   <a:srgbClr val="4C606E"/>
@@ -14622,6 +15230,7 @@
               </a:defRPr>
             </a:lvl8pPr>
             <a:lvl9pPr>
+              <a:buNone/>
               <a:defRPr sz="1950" b="0">
                 <a:solidFill>
                   <a:srgbClr val="4C606E"/>
@@ -14634,6 +15243,7 @@
           </a:lstStyle>
           <a:p xmlns:a="http://schemas.openxmlformats.org/drawingml/2006/main">
             <a:pPr>
+              <a:buNone/>
               <a:defRPr sz="1950" b="0">
                 <a:solidFill>
                   <a:srgbClr val="4C606E"/>
@@ -14700,6 +15310,7 @@
               </a:defRPr>
             </a:defPPr>
             <a:lvl1pPr>
+              <a:buNone/>
               <a:defRPr sz="1950" b="0">
                 <a:solidFill>
                   <a:srgbClr val="4C606E"/>
@@ -14710,6 +15321,7 @@
               </a:defRPr>
             </a:lvl1pPr>
             <a:lvl2pPr>
+              <a:buNone/>
               <a:defRPr sz="1950" b="0">
                 <a:solidFill>
                   <a:srgbClr val="4C606E"/>
@@ -14720,6 +15332,7 @@
               </a:defRPr>
             </a:lvl2pPr>
             <a:lvl3pPr>
+              <a:buNone/>
               <a:defRPr sz="1950" b="0">
                 <a:solidFill>
                   <a:srgbClr val="4C606E"/>
@@ -14730,6 +15343,7 @@
               </a:defRPr>
             </a:lvl3pPr>
             <a:lvl4pPr>
+              <a:buNone/>
               <a:defRPr sz="1950" b="0">
                 <a:solidFill>
                   <a:srgbClr val="4C606E"/>
@@ -14740,6 +15354,7 @@
               </a:defRPr>
             </a:lvl4pPr>
             <a:lvl5pPr>
+              <a:buNone/>
               <a:defRPr sz="1950" b="0">
                 <a:solidFill>
                   <a:srgbClr val="4C606E"/>
@@ -14750,6 +15365,7 @@
               </a:defRPr>
             </a:lvl5pPr>
             <a:lvl6pPr>
+              <a:buNone/>
               <a:defRPr sz="1950" b="0">
                 <a:solidFill>
                   <a:srgbClr val="4C606E"/>
@@ -14760,6 +15376,7 @@
               </a:defRPr>
             </a:lvl6pPr>
             <a:lvl7pPr>
+              <a:buNone/>
               <a:defRPr sz="1950" b="0">
                 <a:solidFill>
                   <a:srgbClr val="4C606E"/>
@@ -14770,6 +15387,7 @@
               </a:defRPr>
             </a:lvl7pPr>
             <a:lvl8pPr>
+              <a:buNone/>
               <a:defRPr sz="1950" b="0">
                 <a:solidFill>
                   <a:srgbClr val="4C606E"/>
@@ -14780,6 +15398,7 @@
               </a:defRPr>
             </a:lvl8pPr>
             <a:lvl9pPr>
+              <a:buNone/>
               <a:defRPr sz="1950" b="0">
                 <a:solidFill>
                   <a:srgbClr val="4C606E"/>
@@ -14792,6 +15411,7 @@
           </a:lstStyle>
           <a:p xmlns:a="http://schemas.openxmlformats.org/drawingml/2006/main">
             <a:pPr>
+              <a:buNone/>
               <a:defRPr sz="1950" b="0">
                 <a:solidFill>
                   <a:srgbClr val="4C606E"/>
@@ -14820,7 +15440,7 @@
           <p:cNvPr id="44" name="">
             <a:extLst xmlns:a="http://schemas.openxmlformats.org/drawingml/2006/main">
               <a:ext uri="{FF2B5EF4-FFF2-40B4-BE49-F238E27FC236}">
-                <a16:creationId xmlns:a16="http://schemas.microsoft.com/office/drawing/2014/main" id="{7A61EFAE-08E5-43A1-B32E-D1718699D412}"/>
+                <a16:creationId xmlns:a16="http://schemas.microsoft.com/office/drawing/2014/main" id="{E707BA89-22E3-45F8-82A1-828E8778DE61}"/>
               </a:ext>
             </a:extLst>
           </p:cNvPr>
@@ -14830,7 +15450,7 @@
           <p:nvPr/>
         </p:nvPicPr>
         <p:blipFill>
-          <a:blip xmlns:r="http://schemas.openxmlformats.org/officeDocument/2006/relationships" xmlns:a="http://schemas.openxmlformats.org/drawingml/2006/main" r:embed="R3d2a5962b7f24c91"/>
+          <a:blip xmlns:r="http://schemas.openxmlformats.org/officeDocument/2006/relationships" xmlns:a="http://schemas.openxmlformats.org/drawingml/2006/main" r:embed="R24f90632bdd2456c"/>
           <a:stretch xmlns:a="http://schemas.openxmlformats.org/drawingml/2006/main"/>
         </p:blipFill>
         <p:spPr>
@@ -14886,6 +15506,7 @@
               </a:defRPr>
             </a:defPPr>
             <a:lvl1pPr>
+              <a:buNone/>
               <a:defRPr sz="2175" b="1">
                 <a:solidFill>
                   <a:srgbClr val="132F43"/>
@@ -14896,6 +15517,7 @@
               </a:defRPr>
             </a:lvl1pPr>
             <a:lvl2pPr>
+              <a:buNone/>
               <a:defRPr sz="2175" b="1">
                 <a:solidFill>
                   <a:srgbClr val="132F43"/>
@@ -14906,6 +15528,7 @@
               </a:defRPr>
             </a:lvl2pPr>
             <a:lvl3pPr>
+              <a:buNone/>
               <a:defRPr sz="2175" b="1">
                 <a:solidFill>
                   <a:srgbClr val="132F43"/>
@@ -14916,6 +15539,7 @@
               </a:defRPr>
             </a:lvl3pPr>
             <a:lvl4pPr>
+              <a:buNone/>
               <a:defRPr sz="2175" b="1">
                 <a:solidFill>
                   <a:srgbClr val="132F43"/>
@@ -14926,6 +15550,7 @@
               </a:defRPr>
             </a:lvl4pPr>
             <a:lvl5pPr>
+              <a:buNone/>
               <a:defRPr sz="2175" b="1">
                 <a:solidFill>
                   <a:srgbClr val="132F43"/>
@@ -14936,6 +15561,7 @@
               </a:defRPr>
             </a:lvl5pPr>
             <a:lvl6pPr>
+              <a:buNone/>
               <a:defRPr sz="2175" b="1">
                 <a:solidFill>
                   <a:srgbClr val="132F43"/>
@@ -14946,6 +15572,7 @@
               </a:defRPr>
             </a:lvl6pPr>
             <a:lvl7pPr>
+              <a:buNone/>
               <a:defRPr sz="2175" b="1">
                 <a:solidFill>
                   <a:srgbClr val="132F43"/>
@@ -14956,6 +15583,7 @@
               </a:defRPr>
             </a:lvl7pPr>
             <a:lvl8pPr>
+              <a:buNone/>
               <a:defRPr sz="2175" b="1">
                 <a:solidFill>
                   <a:srgbClr val="132F43"/>
@@ -14966,6 +15594,7 @@
               </a:defRPr>
             </a:lvl8pPr>
             <a:lvl9pPr>
+              <a:buNone/>
               <a:defRPr sz="2175" b="1">
                 <a:solidFill>
                   <a:srgbClr val="132F43"/>
@@ -14978,6 +15607,7 @@
           </a:lstStyle>
           <a:p xmlns:a="http://schemas.openxmlformats.org/drawingml/2006/main">
             <a:pPr>
+              <a:buNone/>
               <a:defRPr sz="2175" b="1">
                 <a:solidFill>
                   <a:srgbClr val="132F43"/>
@@ -14997,6 +15627,345 @@
                 <a:cs typeface="Malgun Gothic"/>
               </a:rPr>
               <a:t>논문 · 코드 · 실험</a:t>
+            </a:r>
+          </a:p>
+        </p:txBody>
+      </p:sp>
+      <p:sp>
+        <p:nvSpPr>
+          <p:cNvPr id="47" name="">
+            <a:extLst xmlns:a="http://schemas.openxmlformats.org/drawingml/2006/main">
+              <a:ext uri="{FF2B5EF4-FFF2-40B4-BE49-F238E27FC236}">
+                <a16:creationId xmlns:a16="http://schemas.microsoft.com/office/drawing/2014/main" id="{343CA1BA-1BAE-4F5B-90FB-93D3C065623D}"/>
+              </a:ext>
+            </a:extLst>
+          </p:cNvPr>
+          <p:cNvSpPr>
+            <a:spLocks xmlns:a="http://schemas.openxmlformats.org/drawingml/2006/main" noGrp="1"/>
+          </p:cNvSpPr>
+          <p:nvPr/>
+        </p:nvSpPr>
+        <p:spPr>
+          <a:xfrm xmlns:a="http://schemas.openxmlformats.org/drawingml/2006/main">
+            <a:off x="1238250" y="17430750"/>
+            <a:ext cx="13239750" cy="1000125"/>
+          </a:xfrm>
+          <a:prstGeom xmlns:a="http://schemas.openxmlformats.org/drawingml/2006/main" prst="rect">
+            <a:avLst/>
+          </a:prstGeom>
+          <a:noFill xmlns:a="http://schemas.openxmlformats.org/drawingml/2006/main"/>
+          <a:ln xmlns:a="http://schemas.openxmlformats.org/drawingml/2006/main" w="0">
+            <a:noFill/>
+          </a:ln>
+        </p:spPr>
+        <p:txBody>
+          <a:bodyPr xmlns:a="http://schemas.openxmlformats.org/drawingml/2006/main">
+            <a:noAutofit/>
+          </a:bodyPr>
+          <a:lstStyle xmlns:a="http://schemas.openxmlformats.org/drawingml/2006/main">
+            <a:defPPr>
+              <a:defRPr sz="2550">
+                <a:solidFill>
+                  <a:srgbClr val="4C606E"/>
+                </a:solidFill>
+                <a:latin typeface="Malgun Gothic"/>
+                <a:ea typeface="Malgun Gothic"/>
+                <a:cs typeface="Malgun Gothic"/>
+              </a:defRPr>
+            </a:defPPr>
+            <a:lvl1pPr>
+              <a:defRPr sz="2550">
+                <a:solidFill>
+                  <a:srgbClr val="4C606E"/>
+                </a:solidFill>
+                <a:latin typeface="Malgun Gothic"/>
+                <a:ea typeface="Malgun Gothic"/>
+                <a:cs typeface="Malgun Gothic"/>
+              </a:defRPr>
+            </a:lvl1pPr>
+            <a:lvl2pPr>
+              <a:defRPr sz="2550">
+                <a:solidFill>
+                  <a:srgbClr val="4C606E"/>
+                </a:solidFill>
+                <a:latin typeface="Malgun Gothic"/>
+                <a:ea typeface="Malgun Gothic"/>
+                <a:cs typeface="Malgun Gothic"/>
+              </a:defRPr>
+            </a:lvl2pPr>
+            <a:lvl3pPr>
+              <a:defRPr sz="2550">
+                <a:solidFill>
+                  <a:srgbClr val="4C606E"/>
+                </a:solidFill>
+                <a:latin typeface="Malgun Gothic"/>
+                <a:ea typeface="Malgun Gothic"/>
+                <a:cs typeface="Malgun Gothic"/>
+              </a:defRPr>
+            </a:lvl3pPr>
+            <a:lvl4pPr>
+              <a:defRPr sz="2550">
+                <a:solidFill>
+                  <a:srgbClr val="4C606E"/>
+                </a:solidFill>
+                <a:latin typeface="Malgun Gothic"/>
+                <a:ea typeface="Malgun Gothic"/>
+                <a:cs typeface="Malgun Gothic"/>
+              </a:defRPr>
+            </a:lvl4pPr>
+            <a:lvl5pPr>
+              <a:defRPr sz="2550">
+                <a:solidFill>
+                  <a:srgbClr val="4C606E"/>
+                </a:solidFill>
+                <a:latin typeface="Malgun Gothic"/>
+                <a:ea typeface="Malgun Gothic"/>
+                <a:cs typeface="Malgun Gothic"/>
+              </a:defRPr>
+            </a:lvl5pPr>
+            <a:lvl6pPr>
+              <a:defRPr sz="2550">
+                <a:solidFill>
+                  <a:srgbClr val="4C606E"/>
+                </a:solidFill>
+                <a:latin typeface="Malgun Gothic"/>
+                <a:ea typeface="Malgun Gothic"/>
+                <a:cs typeface="Malgun Gothic"/>
+              </a:defRPr>
+            </a:lvl6pPr>
+            <a:lvl7pPr>
+              <a:defRPr sz="2550">
+                <a:solidFill>
+                  <a:srgbClr val="4C606E"/>
+                </a:solidFill>
+                <a:latin typeface="Malgun Gothic"/>
+                <a:ea typeface="Malgun Gothic"/>
+                <a:cs typeface="Malgun Gothic"/>
+              </a:defRPr>
+            </a:lvl7pPr>
+            <a:lvl8pPr>
+              <a:defRPr sz="2550">
+                <a:solidFill>
+                  <a:srgbClr val="4C606E"/>
+                </a:solidFill>
+                <a:latin typeface="Malgun Gothic"/>
+                <a:ea typeface="Malgun Gothic"/>
+                <a:cs typeface="Malgun Gothic"/>
+              </a:defRPr>
+            </a:lvl8pPr>
+            <a:lvl9pPr>
+              <a:defRPr sz="2550">
+                <a:solidFill>
+                  <a:srgbClr val="4C606E"/>
+                </a:solidFill>
+                <a:latin typeface="Malgun Gothic"/>
+                <a:ea typeface="Malgun Gothic"/>
+                <a:cs typeface="Malgun Gothic"/>
+              </a:defRPr>
+            </a:lvl9pPr>
+          </a:lstStyle>
+          <a:p xmlns:a="http://schemas.openxmlformats.org/drawingml/2006/main">
+            <a:pPr>
+              <a:defRPr sz="2550">
+                <a:solidFill>
+                  <a:srgbClr val="4C606E"/>
+                </a:solidFill>
+                <a:latin typeface="Malgun Gothic"/>
+                <a:ea typeface="Malgun Gothic"/>
+                <a:cs typeface="Malgun Gothic"/>
+              </a:defRPr>
+            </a:pPr>
+            <a:r>
+              <a:rPr sz="2550">
+                <a:solidFill>
+                  <a:srgbClr val="4C606E"/>
+                </a:solidFill>
+                <a:latin typeface="Malgun Gothic"/>
+                <a:ea typeface="Malgun Gothic"/>
+                <a:cs typeface="Malgun Gothic"/>
+              </a:rPr>
+              <a:t>특징·계층 분류 선행연구 [2,3]를 토대로,</a:t>
+            </a:r>
+          </a:p>
+          <a:p xmlns:a="http://schemas.openxmlformats.org/drawingml/2006/main">
+            <a:pPr>
+              <a:defRPr sz="2550">
+                <a:solidFill>
+                  <a:srgbClr val="4C606E"/>
+                </a:solidFill>
+                <a:latin typeface="Malgun Gothic"/>
+                <a:ea typeface="Malgun Gothic"/>
+                <a:cs typeface="Malgun Gothic"/>
+              </a:defRPr>
+            </a:pPr>
+            <a:r>
+              <a:rPr sz="2550">
+                <a:solidFill>
+                  <a:srgbClr val="4C606E"/>
+                </a:solidFill>
+                <a:latin typeface="Malgun Gothic"/>
+                <a:ea typeface="Malgun Gothic"/>
+                <a:cs typeface="Malgun Gothic"/>
+              </a:rPr>
+              <a:t>출력 요구별 구성 선택의 실험 근거를 제시한다.</a:t>
+            </a:r>
+          </a:p>
+        </p:txBody>
+      </p:sp>
+      <p:sp>
+        <p:nvSpPr>
+          <p:cNvPr id="48" name="">
+            <a:extLst xmlns:a="http://schemas.openxmlformats.org/drawingml/2006/main">
+              <a:ext uri="{FF2B5EF4-FFF2-40B4-BE49-F238E27FC236}">
+                <a16:creationId xmlns:a16="http://schemas.microsoft.com/office/drawing/2014/main" id="{18A8475D-CBCF-470D-A63C-D913B7D2FC2A}"/>
+              </a:ext>
+            </a:extLst>
+          </p:cNvPr>
+          <p:cNvSpPr>
+            <a:spLocks xmlns:a="http://schemas.openxmlformats.org/drawingml/2006/main" noGrp="1"/>
+          </p:cNvSpPr>
+          <p:nvPr/>
+        </p:nvSpPr>
+        <p:spPr>
+          <a:xfrm xmlns:a="http://schemas.openxmlformats.org/drawingml/2006/main">
+            <a:off x="15716250" y="20669250"/>
+            <a:ext cx="13315950" cy="476250"/>
+          </a:xfrm>
+          <a:prstGeom xmlns:a="http://schemas.openxmlformats.org/drawingml/2006/main" prst="rect">
+            <a:avLst/>
+          </a:prstGeom>
+          <a:noFill xmlns:a="http://schemas.openxmlformats.org/drawingml/2006/main"/>
+          <a:ln xmlns:a="http://schemas.openxmlformats.org/drawingml/2006/main" w="0">
+            <a:noFill/>
+          </a:ln>
+        </p:spPr>
+        <p:txBody>
+          <a:bodyPr xmlns:a="http://schemas.openxmlformats.org/drawingml/2006/main">
+            <a:noAutofit/>
+          </a:bodyPr>
+          <a:lstStyle xmlns:a="http://schemas.openxmlformats.org/drawingml/2006/main">
+            <a:defPPr>
+              <a:defRPr sz="2250">
+                <a:solidFill>
+                  <a:srgbClr val="4C606E"/>
+                </a:solidFill>
+                <a:latin typeface="Malgun Gothic"/>
+                <a:ea typeface="Malgun Gothic"/>
+                <a:cs typeface="Malgun Gothic"/>
+              </a:defRPr>
+            </a:defPPr>
+            <a:lvl1pPr>
+              <a:defRPr sz="2250">
+                <a:solidFill>
+                  <a:srgbClr val="4C606E"/>
+                </a:solidFill>
+                <a:latin typeface="Malgun Gothic"/>
+                <a:ea typeface="Malgun Gothic"/>
+                <a:cs typeface="Malgun Gothic"/>
+              </a:defRPr>
+            </a:lvl1pPr>
+            <a:lvl2pPr>
+              <a:defRPr sz="2250">
+                <a:solidFill>
+                  <a:srgbClr val="4C606E"/>
+                </a:solidFill>
+                <a:latin typeface="Malgun Gothic"/>
+                <a:ea typeface="Malgun Gothic"/>
+                <a:cs typeface="Malgun Gothic"/>
+              </a:defRPr>
+            </a:lvl2pPr>
+            <a:lvl3pPr>
+              <a:defRPr sz="2250">
+                <a:solidFill>
+                  <a:srgbClr val="4C606E"/>
+                </a:solidFill>
+                <a:latin typeface="Malgun Gothic"/>
+                <a:ea typeface="Malgun Gothic"/>
+                <a:cs typeface="Malgun Gothic"/>
+              </a:defRPr>
+            </a:lvl3pPr>
+            <a:lvl4pPr>
+              <a:defRPr sz="2250">
+                <a:solidFill>
+                  <a:srgbClr val="4C606E"/>
+                </a:solidFill>
+                <a:latin typeface="Malgun Gothic"/>
+                <a:ea typeface="Malgun Gothic"/>
+                <a:cs typeface="Malgun Gothic"/>
+              </a:defRPr>
+            </a:lvl4pPr>
+            <a:lvl5pPr>
+              <a:defRPr sz="2250">
+                <a:solidFill>
+                  <a:srgbClr val="4C606E"/>
+                </a:solidFill>
+                <a:latin typeface="Malgun Gothic"/>
+                <a:ea typeface="Malgun Gothic"/>
+                <a:cs typeface="Malgun Gothic"/>
+              </a:defRPr>
+            </a:lvl5pPr>
+            <a:lvl6pPr>
+              <a:defRPr sz="2250">
+                <a:solidFill>
+                  <a:srgbClr val="4C606E"/>
+                </a:solidFill>
+                <a:latin typeface="Malgun Gothic"/>
+                <a:ea typeface="Malgun Gothic"/>
+                <a:cs typeface="Malgun Gothic"/>
+              </a:defRPr>
+            </a:lvl6pPr>
+            <a:lvl7pPr>
+              <a:defRPr sz="2250">
+                <a:solidFill>
+                  <a:srgbClr val="4C606E"/>
+                </a:solidFill>
+                <a:latin typeface="Malgun Gothic"/>
+                <a:ea typeface="Malgun Gothic"/>
+                <a:cs typeface="Malgun Gothic"/>
+              </a:defRPr>
+            </a:lvl7pPr>
+            <a:lvl8pPr>
+              <a:defRPr sz="2250">
+                <a:solidFill>
+                  <a:srgbClr val="4C606E"/>
+                </a:solidFill>
+                <a:latin typeface="Malgun Gothic"/>
+                <a:ea typeface="Malgun Gothic"/>
+                <a:cs typeface="Malgun Gothic"/>
+              </a:defRPr>
+            </a:lvl8pPr>
+            <a:lvl9pPr>
+              <a:defRPr sz="2250">
+                <a:solidFill>
+                  <a:srgbClr val="4C606E"/>
+                </a:solidFill>
+                <a:latin typeface="Malgun Gothic"/>
+                <a:ea typeface="Malgun Gothic"/>
+                <a:cs typeface="Malgun Gothic"/>
+              </a:defRPr>
+            </a:lvl9pPr>
+          </a:lstStyle>
+          <a:p xmlns:a="http://schemas.openxmlformats.org/drawingml/2006/main">
+            <a:pPr>
+              <a:defRPr sz="2250">
+                <a:solidFill>
+                  <a:srgbClr val="4C606E"/>
+                </a:solidFill>
+                <a:latin typeface="Malgun Gothic"/>
+                <a:ea typeface="Malgun Gothic"/>
+                <a:cs typeface="Malgun Gothic"/>
+              </a:defRPr>
+            </a:pPr>
+            <a:r>
+              <a:rPr sz="2250">
+                <a:solidFill>
+                  <a:srgbClr val="4C606E"/>
+                </a:solidFill>
+                <a:latin typeface="Malgun Gothic"/>
+                <a:ea typeface="Malgun Gothic"/>
+                <a:cs typeface="Malgun Gothic"/>
+              </a:rPr>
+              <a:t>검증의 동일 1구간 · batch 1 · CPU</a:t>
             </a:r>
           </a:p>
         </p:txBody>

</xml_diff>